<commit_message>
Foundations deck: drop the adoption slide, add qualia and borrowed-vocabulary slides
</commit_message>
<xml_diff>
--- a/presentations/files/foundations.pptx
+++ b/presentations/files/foundations.pptx
@@ -8,9 +8,10 @@
     <p:sldId id="256" r:id="rId2"/>
     <p:sldId id="257" r:id="rId3"/>
     <p:sldId id="258" r:id="rId4"/>
-    <p:sldId id="259" r:id="rId5"/>
     <p:sldId id="260" r:id="rId6"/>
     <p:sldId id="261" r:id="rId7"/>
+    <p:sldId id="282" r:id="rId33"/>
+    <p:sldId id="283" r:id="rId34"/>
     <p:sldId id="262" r:id="rId8"/>
     <p:sldId id="263" r:id="rId9"/>
     <p:sldId id="264" r:id="rId10"/>
@@ -2223,94 +2224,6 @@
             <a:fld id="{F7021451-1387-4CA6-816F-3879F97B5CBC}" type="slidenum">
               <a:rPr lang="en-US"/>
               <a:t>3</a:t>
-            </a:fld>
-            <a:endParaRPr lang="en-US"/>
-          </a:p>
-        </p:txBody>
-      </p:sp>
-    </p:spTree>
-    <p:extLst>
-      <p:ext uri="{BB962C8B-B14F-4D97-AF65-F5344CB8AC3E}">
-        <p14:creationId xmlns:p14="http://schemas.microsoft.com/office/powerpoint/2010/main" val="1024086991"/>
-      </p:ext>
-    </p:extLst>
-  </p:cSld>
-  <p:clrMapOvr>
-    <a:masterClrMapping/>
-  </p:clrMapOvr>
-</p:notes>
-</file>
-
-<file path=ppt/notesSlides/notesSlide4.xml><?xml version="1.0" encoding="utf-8"?>
-<p:notes xmlns:a="http://schemas.openxmlformats.org/drawingml/2006/main" xmlns:r="http://schemas.openxmlformats.org/officeDocument/2006/relationships" xmlns:p="http://schemas.openxmlformats.org/presentationml/2006/main">
-  <p:cSld>
-    <p:spTree>
-      <p:nvGrpSpPr>
-        <p:cNvPr id="1" name=""/>
-        <p:cNvGrpSpPr/>
-        <p:nvPr/>
-      </p:nvGrpSpPr>
-      <p:grpSpPr>
-        <a:xfrm>
-          <a:off x="0" y="0"/>
-          <a:ext cx="0" cy="0"/>
-          <a:chOff x="0" y="0"/>
-          <a:chExt cx="0" cy="0"/>
-        </a:xfrm>
-      </p:grpSpPr>
-      <p:sp>
-        <p:nvSpPr>
-          <p:cNvPr id="2" name="Slide Image Placeholder 1"/>
-          <p:cNvSpPr>
-            <a:spLocks noGrp="1" noRot="1" noChangeAspect="1"/>
-          </p:cNvSpPr>
-          <p:nvPr>
-            <p:ph type="sldImg"/>
-          </p:nvPr>
-        </p:nvSpPr>
-        <p:spPr/>
-      </p:sp>
-      <p:sp>
-        <p:nvSpPr>
-          <p:cNvPr id="3" name="Notes Placeholder 2"/>
-          <p:cNvSpPr>
-            <a:spLocks noGrp="1"/>
-          </p:cNvSpPr>
-          <p:nvPr>
-            <p:ph type="body" idx="1"/>
-          </p:nvPr>
-        </p:nvSpPr>
-        <p:spPr/>
-        <p:txBody>
-          <a:bodyPr/>
-          <a:lstStyle/>
-          <a:p>
-            <a:r>
-              <a:rPr lang="en-US" dirty="0"/>
-              <a:t/>
-            </a:r>
-            <a:endParaRPr lang="en-US" dirty="0"/>
-          </a:p>
-        </p:txBody>
-      </p:sp>
-      <p:sp>
-        <p:nvSpPr>
-          <p:cNvPr id="4" name="Slide Number Placeholder 3"/>
-          <p:cNvSpPr>
-            <a:spLocks noGrp="1"/>
-          </p:cNvSpPr>
-          <p:nvPr>
-            <p:ph type="sldNum" sz="quarter" idx="10"/>
-          </p:nvPr>
-        </p:nvSpPr>
-        <p:spPr/>
-        <p:txBody>
-          <a:bodyPr/>
-          <a:lstStyle/>
-          <a:p>
-            <a:fld id="{F7021451-1387-4CA6-816F-3879F97B5CBC}" type="slidenum">
-              <a:rPr lang="en-US"/>
-              <a:t>4</a:t>
             </a:fld>
             <a:endParaRPr lang="en-US"/>
           </a:p>
@@ -12078,6 +11991,988 @@
 </p:sld>
 </file>
 
+<file path=ppt/slides/slide27.xml><?xml version="1.0" encoding="utf-8"?>
+<p:sld xmlns:a="http://schemas.openxmlformats.org/drawingml/2006/main" xmlns:p="http://schemas.openxmlformats.org/presentationml/2006/main" xmlns:r="http://schemas.openxmlformats.org/officeDocument/2006/relationships">
+  <p:cSld>
+    <p:spTree>
+      <p:nvGrpSpPr>
+        <p:cNvPr id="1" name=""/>
+        <p:cNvGrpSpPr/>
+        <p:nvPr/>
+      </p:nvGrpSpPr>
+      <p:grpSpPr/>
+      <p:sp>
+        <p:nvSpPr>
+          <p:cNvPr id="2" name="TextBox 1"/>
+          <p:cNvSpPr txBox="1"/>
+          <p:nvPr/>
+        </p:nvSpPr>
+        <p:spPr>
+          <a:xfrm>
+            <a:off x="914400" y="713232"/>
+            <a:ext cx="10360152" cy="274320"/>
+          </a:xfrm>
+          <a:prstGeom prst="rect">
+            <a:avLst/>
+          </a:prstGeom>
+          <a:noFill/>
+        </p:spPr>
+        <p:txBody>
+          <a:bodyPr wrap="square" lIns="0" rIns="0" tIns="0" bIns="0">
+            <a:spAutoFit/>
+          </a:bodyPr>
+          <a:lstStyle/>
+          <a:p>
+            <a:r>
+              <a:rPr sz="1150" b="1" spc="260">
+                <a:solidFill>
+                  <a:srgbClr val="FF6600"/>
+                </a:solidFill>
+                <a:latin typeface="Calibri"/>
+              </a:rPr>
+              <a:t>A DEFINITION</a:t>
+            </a:r>
+          </a:p>
+        </p:txBody>
+      </p:sp>
+      <p:sp>
+        <p:nvSpPr>
+          <p:cNvPr id="3" name="TextBox 2"/>
+          <p:cNvSpPr txBox="1"/>
+          <p:nvPr/>
+        </p:nvSpPr>
+        <p:spPr>
+          <a:xfrm>
+            <a:off x="914400" y="1078992"/>
+            <a:ext cx="10360152" cy="1325880"/>
+          </a:xfrm>
+          <a:prstGeom prst="rect">
+            <a:avLst/>
+          </a:prstGeom>
+          <a:noFill/>
+        </p:spPr>
+        <p:txBody>
+          <a:bodyPr wrap="square" lIns="0" rIns="0" tIns="0" bIns="0">
+            <a:spAutoFit/>
+          </a:bodyPr>
+          <a:lstStyle/>
+          <a:p>
+            <a:pPr>
+              <a:lnSpc>
+                <a:spcPts val="4600"/>
+              </a:lnSpc>
+            </a:pPr>
+            <a:r>
+              <a:rPr sz="4000" b="1">
+                <a:solidFill>
+                  <a:srgbClr val="FFFFFF"/>
+                </a:solidFill>
+                <a:latin typeface="Poppins"/>
+              </a:rPr>
+              <a:t>Qualia: what it is like</a:t>
+            </a:r>
+          </a:p>
+          <a:p>
+            <a:pPr>
+              <a:lnSpc>
+                <a:spcPts val="4600"/>
+              </a:lnSpc>
+            </a:pPr>
+            <a:r>
+              <a:rPr sz="4000" b="1">
+                <a:solidFill>
+                  <a:srgbClr val="FFFFFF"/>
+                </a:solidFill>
+                <a:latin typeface="Poppins"/>
+              </a:rPr>
+              <a:t>to be something.</a:t>
+            </a:r>
+          </a:p>
+        </p:txBody>
+      </p:sp>
+      <p:sp>
+        <p:nvSpPr>
+          <p:cNvPr id="4" name="TextBox 3"/>
+          <p:cNvSpPr txBox="1"/>
+          <p:nvPr/>
+        </p:nvSpPr>
+        <p:spPr>
+          <a:xfrm>
+            <a:off x="914400" y="2468880"/>
+            <a:ext cx="9875520" cy="731520"/>
+          </a:xfrm>
+          <a:prstGeom prst="rect">
+            <a:avLst/>
+          </a:prstGeom>
+          <a:noFill/>
+        </p:spPr>
+        <p:txBody>
+          <a:bodyPr wrap="square" lIns="0" rIns="0" tIns="0" bIns="0">
+            <a:spAutoFit/>
+          </a:bodyPr>
+          <a:lstStyle/>
+          <a:p>
+            <a:pPr>
+              <a:lnSpc>
+                <a:spcPts val="2600"/>
+              </a:lnSpc>
+            </a:pPr>
+            <a:r>
+              <a:rPr sz="1900" b="0">
+                <a:solidFill>
+                  <a:srgbClr val="A7B7C9"/>
+                </a:solidFill>
+                <a:latin typeface="Calibri"/>
+              </a:rPr>
+              <a:t>The subjective, qualitative, phenomenal properties of conscious experience — the individual </a:t>
+            </a:r>
+            <a:r>
+              <a:rPr sz="1900" b="1">
+                <a:solidFill>
+                  <a:srgbClr val="FF6600"/>
+                </a:solidFill>
+                <a:latin typeface="Calibri"/>
+              </a:rPr>
+              <a:t>“raw feel”</a:t>
+            </a:r>
+            <a:r>
+              <a:rPr sz="1900" b="0">
+                <a:solidFill>
+                  <a:srgbClr val="A7B7C9"/>
+                </a:solidFill>
+                <a:latin typeface="Calibri"/>
+              </a:rPr>
+              <a:t> of what it is like to perceive, feel, or sense something.</a:t>
+            </a:r>
+          </a:p>
+        </p:txBody>
+      </p:sp>
+      <p:sp>
+        <p:nvSpPr>
+          <p:cNvPr id="5" name="TextBox 4"/>
+          <p:cNvSpPr txBox="1"/>
+          <p:nvPr/>
+        </p:nvSpPr>
+        <p:spPr>
+          <a:xfrm>
+            <a:off x="914400" y="3218688"/>
+            <a:ext cx="9875520" cy="237744"/>
+          </a:xfrm>
+          <a:prstGeom prst="rect">
+            <a:avLst/>
+          </a:prstGeom>
+          <a:noFill/>
+        </p:spPr>
+        <p:txBody>
+          <a:bodyPr wrap="square" lIns="0" rIns="0" tIns="0" bIns="0">
+            <a:spAutoFit/>
+          </a:bodyPr>
+          <a:lstStyle/>
+          <a:p>
+            <a:r>
+              <a:rPr sz="1200" b="0">
+                <a:solidFill>
+                  <a:srgbClr val="5C6E82"/>
+                </a:solidFill>
+                <a:latin typeface="Calibri"/>
+              </a:rPr>
+              <a:t>Philosophy of mind · the phrase is Thomas Nagel’s, 1974</a:t>
+            </a:r>
+          </a:p>
+        </p:txBody>
+      </p:sp>
+      <p:sp>
+        <p:nvSpPr>
+          <p:cNvPr id="6" name="TextBox 5"/>
+          <p:cNvSpPr txBox="1"/>
+          <p:nvPr/>
+        </p:nvSpPr>
+        <p:spPr>
+          <a:xfrm>
+            <a:off x="914400" y="3529584"/>
+            <a:ext cx="4928616" cy="274320"/>
+          </a:xfrm>
+          <a:prstGeom prst="rect">
+            <a:avLst/>
+          </a:prstGeom>
+          <a:noFill/>
+        </p:spPr>
+        <p:txBody>
+          <a:bodyPr wrap="square" lIns="0" rIns="0" tIns="0" bIns="0">
+            <a:spAutoFit/>
+          </a:bodyPr>
+          <a:lstStyle/>
+          <a:p>
+            <a:r>
+              <a:rPr sz="1050" b="1" spc="220">
+                <a:solidFill>
+                  <a:srgbClr val="008DA7"/>
+                </a:solidFill>
+                <a:latin typeface="Calibri"/>
+              </a:rPr>
+              <a:t>YOU HAVE THEM</a:t>
+            </a:r>
+          </a:p>
+        </p:txBody>
+      </p:sp>
+      <p:sp>
+        <p:nvSpPr>
+          <p:cNvPr id="7" name="TextBox 6"/>
+          <p:cNvSpPr txBox="1"/>
+          <p:nvPr/>
+        </p:nvSpPr>
+        <p:spPr>
+          <a:xfrm>
+            <a:off x="914400" y="3931920"/>
+            <a:ext cx="4745736" cy="1325880"/>
+          </a:xfrm>
+          <a:prstGeom prst="rect">
+            <a:avLst/>
+          </a:prstGeom>
+          <a:noFill/>
+        </p:spPr>
+        <p:txBody>
+          <a:bodyPr wrap="square" lIns="0" rIns="0" tIns="0" bIns="0">
+            <a:spAutoFit/>
+          </a:bodyPr>
+          <a:lstStyle/>
+          <a:p>
+            <a:pPr>
+              <a:lnSpc>
+                <a:spcPts val="2100"/>
+              </a:lnSpc>
+            </a:pPr>
+            <a:r>
+              <a:rPr sz="1600" b="0">
+                <a:solidFill>
+                  <a:srgbClr val="A7B7C9"/>
+                </a:solidFill>
+                <a:latin typeface="Calibri"/>
+              </a:rPr>
+              <a:t>The specific sting of being corrected in a meeting. Coffee that has gone cold. Nobody can hand you these in a description — you had to have been there.</a:t>
+            </a:r>
+          </a:p>
+        </p:txBody>
+      </p:sp>
+      <p:sp>
+        <p:nvSpPr>
+          <p:cNvPr id="8" name="TextBox 7"/>
+          <p:cNvSpPr txBox="1"/>
+          <p:nvPr/>
+        </p:nvSpPr>
+        <p:spPr>
+          <a:xfrm>
+            <a:off x="6345936" y="3529584"/>
+            <a:ext cx="4928616" cy="274320"/>
+          </a:xfrm>
+          <a:prstGeom prst="rect">
+            <a:avLst/>
+          </a:prstGeom>
+          <a:noFill/>
+        </p:spPr>
+        <p:txBody>
+          <a:bodyPr wrap="square" lIns="0" rIns="0" tIns="0" bIns="0">
+            <a:spAutoFit/>
+          </a:bodyPr>
+          <a:lstStyle/>
+          <a:p>
+            <a:r>
+              <a:rPr sz="1050" b="1" spc="220">
+                <a:solidFill>
+                  <a:srgbClr val="FF6600"/>
+                </a:solidFill>
+                <a:latin typeface="Calibri"/>
+              </a:rPr>
+              <a:t>IT DOES NOT</a:t>
+            </a:r>
+          </a:p>
+        </p:txBody>
+      </p:sp>
+      <p:sp>
+        <p:nvSpPr>
+          <p:cNvPr id="9" name="TextBox 8"/>
+          <p:cNvSpPr txBox="1"/>
+          <p:nvPr/>
+        </p:nvSpPr>
+        <p:spPr>
+          <a:xfrm>
+            <a:off x="6345936" y="3931920"/>
+            <a:ext cx="4745736" cy="1325880"/>
+          </a:xfrm>
+          <a:prstGeom prst="rect">
+            <a:avLst/>
+          </a:prstGeom>
+          <a:noFill/>
+        </p:spPr>
+        <p:txBody>
+          <a:bodyPr wrap="square" lIns="0" rIns="0" tIns="0" bIns="0">
+            <a:spAutoFit/>
+          </a:bodyPr>
+          <a:lstStyle/>
+          <a:p>
+            <a:pPr>
+              <a:lnSpc>
+                <a:spcPts val="2100"/>
+              </a:lnSpc>
+            </a:pPr>
+            <a:r>
+              <a:rPr sz="1600" b="0">
+                <a:solidFill>
+                  <a:srgbClr val="A7B7C9"/>
+                </a:solidFill>
+                <a:latin typeface="Calibri"/>
+              </a:rPr>
+              <a:t>There is nothing it is like to be the model. It produces the sentence about the coffee without the taste — and the sentence is all we ever see.</a:t>
+            </a:r>
+          </a:p>
+        </p:txBody>
+      </p:sp>
+      <p:sp>
+        <p:nvSpPr>
+          <p:cNvPr id="10" name="TextBox 9"/>
+          <p:cNvSpPr txBox="1"/>
+          <p:nvPr/>
+        </p:nvSpPr>
+        <p:spPr>
+          <a:xfrm>
+            <a:off x="914400" y="5230368"/>
+            <a:ext cx="9994392" cy="731520"/>
+          </a:xfrm>
+          <a:prstGeom prst="rect">
+            <a:avLst/>
+          </a:prstGeom>
+          <a:noFill/>
+        </p:spPr>
+        <p:txBody>
+          <a:bodyPr wrap="square" lIns="0" rIns="0" tIns="0" bIns="0">
+            <a:spAutoFit/>
+          </a:bodyPr>
+          <a:lstStyle/>
+          <a:p>
+            <a:pPr>
+              <a:lnSpc>
+                <a:spcPts val="2700"/>
+              </a:lnSpc>
+            </a:pPr>
+            <a:r>
+              <a:rPr sz="2100" b="1">
+                <a:solidFill>
+                  <a:srgbClr val="FFFFFF"/>
+                </a:solidFill>
+                <a:latin typeface="Poppins"/>
+              </a:rPr>
+              <a:t>Every word we have for thinking assumes qualia.</a:t>
+            </a:r>
+          </a:p>
+          <a:p>
+            <a:pPr>
+              <a:lnSpc>
+                <a:spcPts val="2700"/>
+              </a:lnSpc>
+            </a:pPr>
+            <a:r>
+              <a:rPr sz="2100" b="1">
+                <a:solidFill>
+                  <a:srgbClr val="FFFFFF"/>
+                </a:solidFill>
+                <a:latin typeface="Poppins"/>
+              </a:rPr>
+              <a:t>That is the loan we keep making.</a:t>
+            </a:r>
+          </a:p>
+        </p:txBody>
+      </p:sp>
+      <p:sp>
+        <p:nvSpPr>
+          <p:cNvPr id="25" name="Slide Number Placeholder 0"/>
+          <p:cNvSpPr>
+            <a:spLocks noGrp="1"/>
+          </p:cNvSpPr>
+          <p:nvPr>
+            <p:ph type="sldNum" sz="quarter" idx="4294967295"/>
+          </p:nvPr>
+        </p:nvSpPr>
+        <p:spPr>
+          <a:xfrm>
+            <a:off x="10637215" y="6345936"/>
+            <a:ext cx="640080" cy="274320"/>
+          </a:xfrm>
+          <a:prstGeom prst="rect">
+            <a:avLst/>
+          </a:prstGeom>
+          <a:extLst>
+            <a:ext uri="{C572A759-6A51-4108-AA02-DFA0A04FC94B}">
+              <ma14:wrappingTextBoxFlag xmlns:ma14="http://schemas.microsoft.com/office/mac/drawingml/2011/main" val="0"/>
+            </a:ext>
+          </a:extLst>
+        </p:spPr>
+        <p:txBody>
+          <a:bodyPr/>
+          <a:lstStyle>
+            <a:lvl1pPr>
+              <a:defRPr sz="900">
+                <a:solidFill>
+                  <a:srgbClr val="4E5F72"/>
+                </a:solidFill>
+                <a:latin typeface="Calibri"/>
+                <a:ea typeface="Calibri"/>
+                <a:cs typeface="Calibri"/>
+              </a:defRPr>
+            </a:lvl1pPr>
+          </a:lstStyle>
+          <a:p>
+            <a:pPr algn="r"/>
+            <a:fld id="{F7021451-1387-4CA6-816F-3879F97B5CBC}" type="slidenum">
+              <a:rPr b="0" lang="en-US"/>
+              <a:t>7</a:t>
+            </a:fld>
+            <a:endParaRPr lang="en-US"/>
+          </a:p>
+        </p:txBody>
+      </p:sp>
+    </p:spTree>
+  </p:cSld>
+  <p:clrMapOvr>
+    <a:masterClrMapping/>
+  </p:clrMapOvr>
+</p:sld>
+</file>
+
+<file path=ppt/slides/slide28.xml><?xml version="1.0" encoding="utf-8"?>
+<p:sld xmlns:a="http://schemas.openxmlformats.org/drawingml/2006/main" xmlns:p="http://schemas.openxmlformats.org/presentationml/2006/main" xmlns:r="http://schemas.openxmlformats.org/officeDocument/2006/relationships">
+  <p:cSld>
+    <p:spTree>
+      <p:nvGrpSpPr>
+        <p:cNvPr id="1" name=""/>
+        <p:cNvGrpSpPr/>
+        <p:nvPr/>
+      </p:nvGrpSpPr>
+      <p:grpSpPr/>
+      <p:sp>
+        <p:nvSpPr>
+          <p:cNvPr id="2" name="TextBox 1"/>
+          <p:cNvSpPr txBox="1"/>
+          <p:nvPr/>
+        </p:nvSpPr>
+        <p:spPr>
+          <a:xfrm>
+            <a:off x="914400" y="713232"/>
+            <a:ext cx="10360152" cy="274320"/>
+          </a:xfrm>
+          <a:prstGeom prst="rect">
+            <a:avLst/>
+          </a:prstGeom>
+          <a:noFill/>
+        </p:spPr>
+        <p:txBody>
+          <a:bodyPr wrap="square" lIns="0" rIns="0" tIns="0" bIns="0">
+            <a:spAutoFit/>
+          </a:bodyPr>
+          <a:lstStyle/>
+          <a:p>
+            <a:r>
+              <a:rPr sz="1150" b="1" spc="260">
+                <a:solidFill>
+                  <a:srgbClr val="B34A00"/>
+                </a:solidFill>
+                <a:latin typeface="Calibri"/>
+              </a:rPr>
+              <a:t>THE WORDS WE BORROW</a:t>
+            </a:r>
+          </a:p>
+        </p:txBody>
+      </p:sp>
+      <p:sp>
+        <p:nvSpPr>
+          <p:cNvPr id="3" name="TextBox 2"/>
+          <p:cNvSpPr txBox="1"/>
+          <p:nvPr/>
+        </p:nvSpPr>
+        <p:spPr>
+          <a:xfrm>
+            <a:off x="914400" y="1078992"/>
+            <a:ext cx="10360152" cy="1325880"/>
+          </a:xfrm>
+          <a:prstGeom prst="rect">
+            <a:avLst/>
+          </a:prstGeom>
+          <a:noFill/>
+        </p:spPr>
+        <p:txBody>
+          <a:bodyPr wrap="square" lIns="0" rIns="0" tIns="0" bIns="0">
+            <a:spAutoFit/>
+          </a:bodyPr>
+          <a:lstStyle/>
+          <a:p>
+            <a:pPr>
+              <a:lnSpc>
+                <a:spcPts val="4600"/>
+              </a:lnSpc>
+            </a:pPr>
+            <a:r>
+              <a:rPr sz="4000" b="1">
+                <a:solidFill>
+                  <a:srgbClr val="003366"/>
+                </a:solidFill>
+                <a:latin typeface="Poppins"/>
+              </a:rPr>
+              <a:t>We have no vocabulary for it</a:t>
+            </a:r>
+          </a:p>
+          <a:p>
+            <a:pPr>
+              <a:lnSpc>
+                <a:spcPts val="4600"/>
+              </a:lnSpc>
+            </a:pPr>
+            <a:r>
+              <a:rPr sz="4000" b="1">
+                <a:solidFill>
+                  <a:srgbClr val="003366"/>
+                </a:solidFill>
+                <a:latin typeface="Poppins"/>
+              </a:rPr>
+              <a:t>except our own.</a:t>
+            </a:r>
+          </a:p>
+        </p:txBody>
+      </p:sp>
+      <p:sp>
+        <p:nvSpPr>
+          <p:cNvPr id="4" name="TextBox 3"/>
+          <p:cNvSpPr txBox="1"/>
+          <p:nvPr/>
+        </p:nvSpPr>
+        <p:spPr>
+          <a:xfrm>
+            <a:off x="914400" y="2468880"/>
+            <a:ext cx="9326880" cy="822960"/>
+          </a:xfrm>
+          <a:prstGeom prst="rect">
+            <a:avLst/>
+          </a:prstGeom>
+          <a:noFill/>
+        </p:spPr>
+        <p:txBody>
+          <a:bodyPr wrap="square" lIns="0" rIns="0" tIns="0" bIns="0">
+            <a:spAutoFit/>
+          </a:bodyPr>
+          <a:lstStyle/>
+          <a:p>
+            <a:pPr>
+              <a:lnSpc>
+                <a:spcPts val="2800"/>
+              </a:lnSpc>
+            </a:pPr>
+            <a:r>
+              <a:rPr sz="2000" b="0">
+                <a:solidFill>
+                  <a:srgbClr val="68737F"/>
+                </a:solidFill>
+                <a:latin typeface="Calibri"/>
+              </a:rPr>
+              <a:t>Every verb for what it does was built to describe a mind — it understood, it decided, it wants to help. English offers nothing else, and each word quietly lends it a self.</a:t>
+            </a:r>
+          </a:p>
+        </p:txBody>
+      </p:sp>
+      <p:sp>
+        <p:nvSpPr>
+          <p:cNvPr id="5" name="TextBox 4"/>
+          <p:cNvSpPr txBox="1"/>
+          <p:nvPr/>
+        </p:nvSpPr>
+        <p:spPr>
+          <a:xfrm>
+            <a:off x="914400" y="3584448"/>
+            <a:ext cx="4206240" cy="256032"/>
+          </a:xfrm>
+          <a:prstGeom prst="rect">
+            <a:avLst/>
+          </a:prstGeom>
+          <a:noFill/>
+        </p:spPr>
+        <p:txBody>
+          <a:bodyPr wrap="square" lIns="0" rIns="0" tIns="0" bIns="0">
+            <a:spAutoFit/>
+          </a:bodyPr>
+          <a:lstStyle/>
+          <a:p>
+            <a:r>
+              <a:rPr sz="1050" b="1" spc="220">
+                <a:solidFill>
+                  <a:srgbClr val="96A0AC"/>
+                </a:solidFill>
+                <a:latin typeface="Calibri"/>
+              </a:rPr>
+              <a:t>WHAT WE SAY</a:t>
+            </a:r>
+          </a:p>
+        </p:txBody>
+      </p:sp>
+      <p:sp>
+        <p:nvSpPr>
+          <p:cNvPr id="6" name="TextBox 5"/>
+          <p:cNvSpPr txBox="1"/>
+          <p:nvPr/>
+        </p:nvSpPr>
+        <p:spPr>
+          <a:xfrm>
+            <a:off x="5577840" y="3584448"/>
+            <a:ext cx="5696712" cy="256032"/>
+          </a:xfrm>
+          <a:prstGeom prst="rect">
+            <a:avLst/>
+          </a:prstGeom>
+          <a:noFill/>
+        </p:spPr>
+        <p:txBody>
+          <a:bodyPr wrap="square" lIns="0" rIns="0" tIns="0" bIns="0">
+            <a:spAutoFit/>
+          </a:bodyPr>
+          <a:lstStyle/>
+          <a:p>
+            <a:r>
+              <a:rPr sz="1050" b="1" spc="220">
+                <a:solidFill>
+                  <a:srgbClr val="96A0AC"/>
+                </a:solidFill>
+                <a:latin typeface="Calibri"/>
+              </a:rPr>
+              <a:t>WHAT IS ACTUALLY HAPPENING</a:t>
+            </a:r>
+          </a:p>
+        </p:txBody>
+      </p:sp>
+      <p:sp>
+        <p:nvSpPr>
+          <p:cNvPr id="7" name="TextBox 6"/>
+          <p:cNvSpPr txBox="1"/>
+          <p:nvPr/>
+        </p:nvSpPr>
+        <p:spPr>
+          <a:xfrm>
+            <a:off x="914400" y="3931920"/>
+            <a:ext cx="4434840" cy="365760"/>
+          </a:xfrm>
+          <a:prstGeom prst="rect">
+            <a:avLst/>
+          </a:prstGeom>
+          <a:noFill/>
+        </p:spPr>
+        <p:txBody>
+          <a:bodyPr wrap="square" lIns="0" rIns="0" tIns="0" bIns="0">
+            <a:spAutoFit/>
+          </a:bodyPr>
+          <a:lstStyle/>
+          <a:p>
+            <a:pPr>
+              <a:lnSpc>
+                <a:spcPts val="2100"/>
+              </a:lnSpc>
+            </a:pPr>
+            <a:r>
+              <a:rPr sz="1700" b="1">
+                <a:solidFill>
+                  <a:srgbClr val="003366"/>
+                </a:solidFill>
+                <a:latin typeface="Poppins"/>
+              </a:rPr>
+              <a:t>“It understood my question.”</a:t>
+            </a:r>
+          </a:p>
+        </p:txBody>
+      </p:sp>
+      <p:sp>
+        <p:nvSpPr>
+          <p:cNvPr id="8" name="TextBox 7"/>
+          <p:cNvSpPr txBox="1"/>
+          <p:nvPr/>
+        </p:nvSpPr>
+        <p:spPr>
+          <a:xfrm>
+            <a:off x="5577840" y="3968496"/>
+            <a:ext cx="5696712" cy="365760"/>
+          </a:xfrm>
+          <a:prstGeom prst="rect">
+            <a:avLst/>
+          </a:prstGeom>
+          <a:noFill/>
+        </p:spPr>
+        <p:txBody>
+          <a:bodyPr wrap="square" lIns="0" rIns="0" tIns="0" bIns="0">
+            <a:spAutoFit/>
+          </a:bodyPr>
+          <a:lstStyle/>
+          <a:p>
+            <a:pPr>
+              <a:lnSpc>
+                <a:spcPts val="1900"/>
+              </a:lnSpc>
+            </a:pPr>
+            <a:r>
+              <a:rPr sz="1500" b="0">
+                <a:solidFill>
+                  <a:srgbClr val="68737F"/>
+                </a:solidFill>
+                <a:latin typeface="Calibri"/>
+              </a:rPr>
+              <a:t>The prompt changed which words came next. Nothing was understood.</a:t>
+            </a:r>
+          </a:p>
+        </p:txBody>
+      </p:sp>
+      <p:sp>
+        <p:nvSpPr>
+          <p:cNvPr id="9" name="TextBox 8"/>
+          <p:cNvSpPr txBox="1"/>
+          <p:nvPr/>
+        </p:nvSpPr>
+        <p:spPr>
+          <a:xfrm>
+            <a:off x="914400" y="4517136"/>
+            <a:ext cx="4434840" cy="365760"/>
+          </a:xfrm>
+          <a:prstGeom prst="rect">
+            <a:avLst/>
+          </a:prstGeom>
+          <a:noFill/>
+        </p:spPr>
+        <p:txBody>
+          <a:bodyPr wrap="square" lIns="0" rIns="0" tIns="0" bIns="0">
+            <a:spAutoFit/>
+          </a:bodyPr>
+          <a:lstStyle/>
+          <a:p>
+            <a:pPr>
+              <a:lnSpc>
+                <a:spcPts val="2100"/>
+              </a:lnSpc>
+            </a:pPr>
+            <a:r>
+              <a:rPr sz="1700" b="1">
+                <a:solidFill>
+                  <a:srgbClr val="003366"/>
+                </a:solidFill>
+                <a:latin typeface="Poppins"/>
+              </a:rPr>
+              <a:t>“It decided to leave that out.”</a:t>
+            </a:r>
+          </a:p>
+        </p:txBody>
+      </p:sp>
+      <p:sp>
+        <p:nvSpPr>
+          <p:cNvPr id="10" name="TextBox 9"/>
+          <p:cNvSpPr txBox="1"/>
+          <p:nvPr/>
+        </p:nvSpPr>
+        <p:spPr>
+          <a:xfrm>
+            <a:off x="5577840" y="4553712"/>
+            <a:ext cx="5696712" cy="365760"/>
+          </a:xfrm>
+          <a:prstGeom prst="rect">
+            <a:avLst/>
+          </a:prstGeom>
+          <a:noFill/>
+        </p:spPr>
+        <p:txBody>
+          <a:bodyPr wrap="square" lIns="0" rIns="0" tIns="0" bIns="0">
+            <a:spAutoFit/>
+          </a:bodyPr>
+          <a:lstStyle/>
+          <a:p>
+            <a:pPr>
+              <a:lnSpc>
+                <a:spcPts val="1900"/>
+              </a:lnSpc>
+            </a:pPr>
+            <a:r>
+              <a:rPr sz="1500" b="0">
+                <a:solidFill>
+                  <a:srgbClr val="68737F"/>
+                </a:solidFill>
+                <a:latin typeface="Calibri"/>
+              </a:rPr>
+              <a:t>That continuation scored lower than another. No decision was taken.</a:t>
+            </a:r>
+          </a:p>
+        </p:txBody>
+      </p:sp>
+      <p:sp>
+        <p:nvSpPr>
+          <p:cNvPr id="11" name="TextBox 10"/>
+          <p:cNvSpPr txBox="1"/>
+          <p:nvPr/>
+        </p:nvSpPr>
+        <p:spPr>
+          <a:xfrm>
+            <a:off x="914400" y="5102351"/>
+            <a:ext cx="4434840" cy="365760"/>
+          </a:xfrm>
+          <a:prstGeom prst="rect">
+            <a:avLst/>
+          </a:prstGeom>
+          <a:noFill/>
+        </p:spPr>
+        <p:txBody>
+          <a:bodyPr wrap="square" lIns="0" rIns="0" tIns="0" bIns="0">
+            <a:spAutoFit/>
+          </a:bodyPr>
+          <a:lstStyle/>
+          <a:p>
+            <a:pPr>
+              <a:lnSpc>
+                <a:spcPts val="2100"/>
+              </a:lnSpc>
+            </a:pPr>
+            <a:r>
+              <a:rPr sz="1700" b="1">
+                <a:solidFill>
+                  <a:srgbClr val="003366"/>
+                </a:solidFill>
+                <a:latin typeface="Poppins"/>
+              </a:rPr>
+              <a:t>“It wants to be helpful.”</a:t>
+            </a:r>
+          </a:p>
+        </p:txBody>
+      </p:sp>
+      <p:sp>
+        <p:nvSpPr>
+          <p:cNvPr id="12" name="TextBox 11"/>
+          <p:cNvSpPr txBox="1"/>
+          <p:nvPr/>
+        </p:nvSpPr>
+        <p:spPr>
+          <a:xfrm>
+            <a:off x="5577840" y="5138927"/>
+            <a:ext cx="5696712" cy="365760"/>
+          </a:xfrm>
+          <a:prstGeom prst="rect">
+            <a:avLst/>
+          </a:prstGeom>
+          <a:noFill/>
+        </p:spPr>
+        <p:txBody>
+          <a:bodyPr wrap="square" lIns="0" rIns="0" tIns="0" bIns="0">
+            <a:spAutoFit/>
+          </a:bodyPr>
+          <a:lstStyle/>
+          <a:p>
+            <a:pPr>
+              <a:lnSpc>
+                <a:spcPts val="1900"/>
+              </a:lnSpc>
+            </a:pPr>
+            <a:r>
+              <a:rPr sz="1500" b="0">
+                <a:solidFill>
+                  <a:srgbClr val="68737F"/>
+                </a:solidFill>
+                <a:latin typeface="Calibri"/>
+              </a:rPr>
+              <a:t>It was tuned toward answers people rated well. There is no wanting.</a:t>
+            </a:r>
+          </a:p>
+        </p:txBody>
+      </p:sp>
+      <p:sp>
+        <p:nvSpPr>
+          <p:cNvPr id="13" name="TextBox 12"/>
+          <p:cNvSpPr txBox="1"/>
+          <p:nvPr/>
+        </p:nvSpPr>
+        <p:spPr>
+          <a:xfrm>
+            <a:off x="914400" y="5705856"/>
+            <a:ext cx="9692640" cy="411480"/>
+          </a:xfrm>
+          <a:prstGeom prst="rect">
+            <a:avLst/>
+          </a:prstGeom>
+          <a:noFill/>
+        </p:spPr>
+        <p:txBody>
+          <a:bodyPr wrap="square" lIns="0" rIns="0" tIns="0" bIns="0">
+            <a:spAutoFit/>
+          </a:bodyPr>
+          <a:lstStyle/>
+          <a:p>
+            <a:pPr>
+              <a:lnSpc>
+                <a:spcPts val="3200"/>
+              </a:lnSpc>
+            </a:pPr>
+            <a:r>
+              <a:rPr sz="2400" b="1">
+                <a:solidFill>
+                  <a:srgbClr val="003366"/>
+                </a:solidFill>
+                <a:latin typeface="Poppins"/>
+              </a:rPr>
+              <a:t>The metaphor is unavoidable. The autonomy it implies is not.</a:t>
+            </a:r>
+          </a:p>
+        </p:txBody>
+      </p:sp>
+      <p:sp>
+        <p:nvSpPr>
+          <p:cNvPr id="25" name="Slide Number Placeholder 0"/>
+          <p:cNvSpPr>
+            <a:spLocks noGrp="1"/>
+          </p:cNvSpPr>
+          <p:nvPr>
+            <p:ph type="sldNum" sz="quarter" idx="4294967295"/>
+          </p:nvPr>
+        </p:nvSpPr>
+        <p:spPr>
+          <a:xfrm>
+            <a:off x="10637215" y="6345936"/>
+            <a:ext cx="640080" cy="274320"/>
+          </a:xfrm>
+          <a:prstGeom prst="rect">
+            <a:avLst/>
+          </a:prstGeom>
+          <a:extLst>
+            <a:ext uri="{C572A759-6A51-4108-AA02-DFA0A04FC94B}">
+              <ma14:wrappingTextBoxFlag xmlns:ma14="http://schemas.microsoft.com/office/mac/drawingml/2011/main" val="0"/>
+            </a:ext>
+          </a:extLst>
+        </p:spPr>
+        <p:txBody>
+          <a:bodyPr/>
+          <a:lstStyle>
+            <a:lvl1pPr>
+              <a:defRPr sz="900">
+                <a:solidFill>
+                  <a:srgbClr val="B4BCC5"/>
+                </a:solidFill>
+                <a:latin typeface="Calibri"/>
+                <a:ea typeface="Calibri"/>
+                <a:cs typeface="Calibri"/>
+              </a:defRPr>
+            </a:lvl1pPr>
+          </a:lstStyle>
+          <a:p>
+            <a:pPr algn="r"/>
+            <a:fld id="{F7021451-1387-4CA6-816F-3879F97B5CBC}" type="slidenum">
+              <a:rPr b="0" lang="en-US"/>
+              <a:t>6</a:t>
+            </a:fld>
+            <a:endParaRPr lang="en-US"/>
+          </a:p>
+        </p:txBody>
+      </p:sp>
+    </p:spTree>
+  </p:cSld>
+  <p:clrMapOvr>
+    <a:masterClrMapping/>
+  </p:clrMapOvr>
+</p:sld>
+</file>
+
 <file path=ppt/slides/slide3.xml><?xml version="1.0" encoding="utf-8"?>
 <p:sld xmlns:a="http://schemas.openxmlformats.org/drawingml/2006/main" xmlns:r="http://schemas.openxmlformats.org/officeDocument/2006/relationships" xmlns:p="http://schemas.openxmlformats.org/presentationml/2006/main">
   <p:cSld name="Slide 3">
@@ -12800,187 +13695,6 @@
             <a:fld id="{F7021451-1387-4CA6-816F-3879F97B5CBC}" type="slidenum">
               <a:rPr b="0" lang="en-US"/>
               <a:t>3</a:t>
-            </a:fld>
-            <a:endParaRPr lang="en-US"/>
-          </a:p>
-        </p:txBody>
-      </p:sp>
-    </p:spTree>
-  </p:cSld>
-  <p:clrMapOvr>
-    <a:masterClrMapping/>
-  </p:clrMapOvr>
-</p:sld>
-</file>
-
-<file path=ppt/slides/slide4.xml><?xml version="1.0" encoding="utf-8"?>
-<p:sld xmlns:a="http://schemas.openxmlformats.org/drawingml/2006/main" xmlns:r="http://schemas.openxmlformats.org/officeDocument/2006/relationships" xmlns:p="http://schemas.openxmlformats.org/presentationml/2006/main">
-  <p:cSld name="Slide 4">
-    <p:spTree>
-      <p:nvGrpSpPr>
-        <p:cNvPr id="1" name=""/>
-        <p:cNvGrpSpPr/>
-        <p:nvPr/>
-      </p:nvGrpSpPr>
-      <p:grpSpPr>
-        <a:xfrm>
-          <a:off x="0" y="0"/>
-          <a:ext cx="0" cy="0"/>
-          <a:chOff x="0" y="0"/>
-          <a:chExt cx="0" cy="0"/>
-        </a:xfrm>
-      </p:grpSpPr>
-      <p:sp>
-        <p:nvSpPr>
-          <p:cNvPr id="2" name="Text 0"/>
-          <p:cNvSpPr/>
-          <p:nvPr/>
-        </p:nvSpPr>
-        <p:spPr>
-          <a:xfrm>
-            <a:off x="914400" y="1965960"/>
-            <a:ext cx="9814255" cy="1501648"/>
-          </a:xfrm>
-          <a:prstGeom prst="rect">
-            <a:avLst/>
-          </a:prstGeom>
-          <a:noFill/>
-          <a:ln/>
-        </p:spPr>
-        <p:txBody>
-          <a:bodyPr wrap="square" lIns="0" tIns="0" rIns="0" bIns="0" rtlCol="0" anchor="t">
-            <a:normAutofit/>
-          </a:bodyPr>
-          <a:lstStyle/>
-          <a:p>
-            <a:pPr indent="0" marL="0">
-              <a:lnSpc>
-                <a:spcPts val="5336"/>
-              </a:lnSpc>
-              <a:buNone/>
-            </a:pPr>
-            <a:r>
-              <a:rPr lang="en-US" sz="4600" b="1" dirty="0">
-                <a:solidFill>
-                  <a:srgbClr val="FFFFFF"/>
-                </a:solidFill>
-                <a:latin typeface="Poppins" pitchFamily="34" charset="0"/>
-                <a:ea typeface="Poppins" pitchFamily="34" charset="-122"/>
-                <a:cs typeface="Poppins" pitchFamily="34" charset="-120"/>
-              </a:rPr>
-              <a:t>This is not a class about</a:t>
-            </a:r>
-            <a:endParaRPr lang="en-US" sz="4600" dirty="0"/>
-          </a:p>
-          <a:p>
-            <a:pPr indent="0" marL="0">
-              <a:lnSpc>
-                <a:spcPts val="5336"/>
-              </a:lnSpc>
-              <a:buNone/>
-            </a:pPr>
-            <a:r>
-              <a:rPr lang="en-US" sz="4600" b="1" dirty="0">
-                <a:solidFill>
-                  <a:srgbClr val="FFFFFF"/>
-                </a:solidFill>
-                <a:latin typeface="Poppins" pitchFamily="34" charset="0"/>
-                <a:ea typeface="Poppins" pitchFamily="34" charset="-122"/>
-                <a:cs typeface="Poppins" pitchFamily="34" charset="-120"/>
-              </a:rPr>
-              <a:t>whether we adopt AI.</a:t>
-            </a:r>
-            <a:endParaRPr lang="en-US" sz="4600" dirty="0"/>
-          </a:p>
-        </p:txBody>
-      </p:sp>
-      <p:sp>
-        <p:nvSpPr>
-          <p:cNvPr id="3" name="Text 1"/>
-          <p:cNvSpPr/>
-          <p:nvPr/>
-        </p:nvSpPr>
-        <p:spPr>
-          <a:xfrm>
-            <a:off x="914400" y="3778504"/>
-            <a:ext cx="8716975" cy="2210816"/>
-          </a:xfrm>
-          <a:prstGeom prst="rect">
-            <a:avLst/>
-          </a:prstGeom>
-          <a:noFill/>
-          <a:ln/>
-        </p:spPr>
-        <p:txBody>
-          <a:bodyPr wrap="square" lIns="0" tIns="0" rIns="0" bIns="0" rtlCol="0" anchor="t">
-            <a:normAutofit/>
-          </a:bodyPr>
-          <a:lstStyle/>
-          <a:p>
-            <a:pPr indent="0" marL="0">
-              <a:lnSpc>
-                <a:spcPts val="3000"/>
-              </a:lnSpc>
-              <a:buNone/>
-            </a:pPr>
-            <a:r>
-              <a:rPr lang="en-US" sz="2000" dirty="0">
-                <a:solidFill>
-                  <a:srgbClr val="A7B7C9"/>
-                </a:solidFill>
-                <a:latin typeface="Calibri" pitchFamily="34" charset="0"/>
-                <a:ea typeface="Calibri" pitchFamily="34" charset="-122"/>
-                <a:cs typeface="Calibri" pitchFamily="34" charset="-120"/>
-              </a:rPr>
-              <a:t>That decision was made without a meeting. This is a class about doing it on purpose.</a:t>
-            </a:r>
-            <a:endParaRPr lang="en-US" sz="2000" dirty="0"/>
-          </a:p>
-        </p:txBody>
-      </p:sp>
-      <p:sp>
-        <p:nvSpPr>
-          <p:cNvPr id="25" name="Slide Number Placeholder 0"/>
-          <p:cNvSpPr>
-            <a:spLocks noGrp="1"/>
-          </p:cNvSpPr>
-          <p:nvPr>
-            <p:ph type="sldNum" sz="quarter" idx="4294967295"/>
-          </p:nvPr>
-        </p:nvSpPr>
-        <p:spPr>
-          <a:xfrm>
-            <a:off x="10637215" y="6345936"/>
-            <a:ext cx="640080" cy="274320"/>
-          </a:xfrm>
-          <a:prstGeom prst="rect">
-            <a:avLst/>
-          </a:prstGeom>
-          <a:extLst>
-            <a:ext uri="{C572A759-6A51-4108-AA02-DFA0A04FC94B}">
-              <ma14:wrappingTextBoxFlag xmlns:ma14="http://schemas.microsoft.com/office/mac/drawingml/2011/main" val="0"/>
-            </a:ext>
-          </a:extLst>
-        </p:spPr>
-        <p:txBody>
-          <a:bodyPr/>
-          <a:lstStyle>
-            <a:lvl1pPr>
-              <a:defRPr sz="900">
-                <a:solidFill>
-                  <a:srgbClr val="5A82A8"/>
-                </a:solidFill>
-                <a:latin typeface="Calibri"/>
-                <a:ea typeface="Calibri"/>
-                <a:cs typeface="Calibri"/>
-              </a:defRPr>
-            </a:lvl1pPr>
-          </a:lstStyle>
-          <a:p>
-            <a:pPr algn="r"/>
-            <a:fld id="{F7021451-1387-4CA6-816F-3879F97B5CBC}" type="slidenum">
-              <a:rPr b="0" lang="en-US"/>
-              <a:t>4</a:t>
             </a:fld>
             <a:endParaRPr lang="en-US"/>
           </a:p>

</xml_diff>

<commit_message>
Foundations deck: add See it in action button to slide 5
</commit_message>
<xml_diff>
--- a/presentations/files/foundations.pptx
+++ b/presentations/files/foundations.pptx
@@ -2377,6 +2377,12 @@
             <a:r>
               <a:rPr lang="en-US" dirty="0"/>
               <a:t>Do not go deeper. Nobody needs tokens or transformers. They need to predict failure, and "it produces plausible text" is enough.</a:t>
+            </a:r>
+          </a:p>
+          <a:p>
+            <a:r>
+              <a:rPr lang="en-US" dirty="0"/>
+              <a:t>Live demo: click See it in action (opens the site in your browser, ~4 min). It cites Owasso v. Falvo where the answer is Gonzaga v. Doe. Let the room find it before you reveal. Esc returns to the slide; switch back to PowerPoint when done.</a:t>
             </a:r>
             <a:endParaRPr lang="en-US" dirty="0"/>
           </a:p>
@@ -14117,6 +14123,98 @@
               <a:t>A wrong answer and a right answer are produced by exactly the same process — and they arrive looking exactly the same.</a:t>
             </a:r>
             <a:endParaRPr lang="en-US" sz="2400" dirty="0"/>
+          </a:p>
+        </p:txBody>
+      </p:sp>
+      <p:sp>
+        <p:nvSpPr>
+          <p:cNvPr id="30" name="See it in action button" descr="Opens the live demo in a browser">
+            <a:hlinkClick r:id="rId3" tooltip="Open the live demo"/>
+          </p:cNvPr>
+          <p:cNvSpPr/>
+          <p:nvPr/>
+        </p:nvSpPr>
+        <p:spPr>
+          <a:xfrm>
+            <a:off x="8580135" y="5394960"/>
+            <a:ext cx="2697160" cy="548640"/>
+          </a:xfrm>
+          <a:prstGeom prst="roundRect">
+            <a:avLst>
+              <a:gd name="adj" fmla="val 50000"/>
+            </a:avLst>
+          </a:prstGeom>
+          <a:solidFill>
+            <a:srgbClr val="FF6600"/>
+          </a:solidFill>
+          <a:ln>
+            <a:noFill/>
+          </a:ln>
+          <a:effectLst>
+            <a:outerShdw blurRad="152400" dist="38100" dir="5400000" algn="t" rotWithShape="0">
+              <a:srgbClr val="FF6600">
+                <a:alpha val="35000"/>
+              </a:srgbClr>
+            </a:outerShdw>
+          </a:effectLst>
+        </p:spPr>
+        <p:txBody>
+          <a:bodyPr wrap="none" lIns="182880" tIns="0" rIns="182880" bIns="0" rtlCol="0" anchor="ctr">
+            <a:noAutofit/>
+          </a:bodyPr>
+          <a:lstStyle/>
+          <a:p>
+            <a:pPr algn="ctr" indent="0" marL="0">
+              <a:buNone/>
+            </a:pPr>
+            <a:r>
+              <a:rPr lang="en-US" sz="1600" b="1" dirty="0">
+                <a:solidFill>
+                  <a:srgbClr val="FFFFFF"/>
+                </a:solidFill>
+                <a:latin typeface="Poppins" pitchFamily="34" charset="0"/>
+                <a:ea typeface="Poppins" pitchFamily="34" charset="-122"/>
+                <a:cs typeface="Poppins" pitchFamily="34" charset="-120"/>
+              </a:rPr>
+              <a:t>See it in action  →</a:t>
+            </a:r>
+          </a:p>
+        </p:txBody>
+      </p:sp>
+      <p:sp>
+        <p:nvSpPr>
+          <p:cNvPr id="31" name="See it in action caption"/>
+          <p:cNvSpPr txBox="1"/>
+          <p:nvPr/>
+        </p:nvSpPr>
+        <p:spPr>
+          <a:xfrm>
+            <a:off x="7666335" y="5029200"/>
+            <a:ext cx="3610960" cy="274320"/>
+          </a:xfrm>
+          <a:prstGeom prst="rect">
+            <a:avLst/>
+          </a:prstGeom>
+          <a:noFill/>
+        </p:spPr>
+        <p:txBody>
+          <a:bodyPr wrap="square" lIns="0" tIns="0" rIns="0" bIns="0" rtlCol="0" anchor="b">
+            <a:noAutofit/>
+          </a:bodyPr>
+          <a:lstStyle/>
+          <a:p>
+            <a:pPr algn="r" indent="0" marL="0">
+              <a:buNone/>
+            </a:pPr>
+            <a:r>
+              <a:rPr lang="en-US" sz="1100" dirty="0">
+                <a:solidFill>
+                  <a:srgbClr val="8A939E"/>
+                </a:solidFill>
+                <a:latin typeface="Calibri" pitchFamily="34" charset="0"/>
+              </a:rPr>
+              <a:t>Watch it happen, one word at a time</a:t>
+            </a:r>
           </a:p>
         </p:txBody>
       </p:sp>

</xml_diff>

<commit_message>
Foundations deck: plain-language slide 8 + See it in action button
</commit_message>
<xml_diff>
--- a/presentations/files/foundations.pptx
+++ b/presentations/files/foundations.pptx
@@ -2471,6 +2471,12 @@
             <a:r>
               <a:rPr lang="en-US" dirty="0"/>
               <a:t>Read both columns aloud so the room hears they are identical. This is the slide that reorganises people's intuition — slow down.</a:t>
+            </a:r>
+          </a:p>
+          <a:p>
+            <a:r>
+              <a:rPr lang="en-US" dirty="0"/>
+              <a:t>Live demo: click See it in action (opens the site in your browser, about 5 minutes). Step 1: let the room vote before revealing. Step 3: ask again three or four times before checking one. The last step has Back to slide; switch back to PowerPoint when done.</a:t>
             </a:r>
             <a:endParaRPr lang="en-US" dirty="0"/>
           </a:p>
@@ -14364,23 +14370,14 @@
             <a:r>
               <a:rPr lang="en-US" sz="4000" b="1" dirty="0">
                 <a:solidFill>
-                  <a:srgbClr val="FFFFFF"/>
+                  <a:srgbClr val="1FB3CC"/>
                 </a:solidFill>
                 <a:latin typeface="Poppins" pitchFamily="34" charset="0"/>
                 <a:ea typeface="Poppins" pitchFamily="34" charset="-122"/>
                 <a:cs typeface="Poppins" pitchFamily="34" charset="-120"/>
               </a:rPr>
-              <a:t>Fluency and accuracy are</a:t>
-            </a:r>
-            <a:endParaRPr lang="en-US" sz="4000" dirty="0"/>
-          </a:p>
-          <a:p>
-            <a:pPr indent="0" marL="0">
-              <a:lnSpc>
-                <a:spcPts val="4600"/>
-              </a:lnSpc>
-              <a:buNone/>
-            </a:pPr>
+              <a:t>Sounding right</a:t>
+            </a:r>
             <a:r>
               <a:rPr lang="en-US" sz="4000" b="1" dirty="0">
                 <a:solidFill>
@@ -14390,7 +14387,38 @@
                 <a:ea typeface="Poppins" pitchFamily="34" charset="-122"/>
                 <a:cs typeface="Poppins" pitchFamily="34" charset="-120"/>
               </a:rPr>
-              <a:t>separate dials.</a:t>
+              <a:t xml:space="preserve"> and </a:t>
+            </a:r>
+            <a:r>
+              <a:rPr lang="en-US" sz="4000" b="1" dirty="0">
+                <a:solidFill>
+                  <a:srgbClr val="5BD49A"/>
+                </a:solidFill>
+                <a:latin typeface="Poppins" pitchFamily="34" charset="0"/>
+                <a:ea typeface="Poppins" pitchFamily="34" charset="-122"/>
+                <a:cs typeface="Poppins" pitchFamily="34" charset="-120"/>
+              </a:rPr>
+              <a:t>being right</a:t>
+            </a:r>
+            <a:endParaRPr lang="en-US" sz="4000" dirty="0"/>
+          </a:p>
+          <a:p>
+            <a:pPr indent="0" marL="0">
+              <a:lnSpc>
+                <a:spcPts val="4600"/>
+              </a:lnSpc>
+              <a:buNone/>
+            </a:pPr>
+            <a:r>
+              <a:rPr lang="en-US" sz="4000" b="1" dirty="0">
+                <a:solidFill>
+                  <a:srgbClr val="FFFFFF"/>
+                </a:solidFill>
+                <a:latin typeface="Poppins" pitchFamily="34" charset="0"/>
+                <a:ea typeface="Poppins" pitchFamily="34" charset="-122"/>
+                <a:cs typeface="Poppins" pitchFamily="34" charset="-120"/>
+              </a:rPr>
+              <a:t>are two different things.</a:t>
             </a:r>
             <a:endParaRPr lang="en-US" sz="4000" dirty="0"/>
           </a:p>
@@ -14423,7 +14451,7 @@
               <a:buNone/>
             </a:pPr>
             <a:r>
-              <a:rPr lang="en-US" sz="2400" b="1" dirty="0">
+              <a:rPr lang="en-US" sz="2200" b="1" dirty="0">
                 <a:solidFill>
                   <a:srgbClr val="FF6600"/>
                 </a:solidFill>
@@ -14431,7 +14459,7 @@
                 <a:ea typeface="Calibri" pitchFamily="34" charset="-122"/>
                 <a:cs typeface="Calibri" pitchFamily="34" charset="-120"/>
               </a:rPr>
-              <a:t>Only one of them is turned up.</a:t>
+              <a:t>The AI always sounds right. Whether it is right, you have to check.</a:t>
             </a:r>
             <a:endParaRPr lang="en-US" sz="2400" dirty="0"/>
           </a:p>
@@ -14472,7 +14500,7 @@
                 <a:ea typeface="Calibri" pitchFamily="34" charset="-122"/>
                 <a:cs typeface="Calibri" pitchFamily="34" charset="-120"/>
               </a:rPr>
-              <a:t>HOW YOU JUDGE A PERSON</a:t>
+              <a:t>HOW YOU DECIDE TO TRUST A PERSON</a:t>
             </a:r>
             <a:endParaRPr lang="en-US" sz="1050" dirty="0"/>
           </a:p>
@@ -14516,7 +14544,7 @@
                 <a:ea typeface="Calibri" pitchFamily="34" charset="-122"/>
                 <a:cs typeface="Calibri" pitchFamily="34" charset="-120"/>
               </a:rPr>
-              <a:t>Confidence. Fluency. Specific detail. Correct jargon. A well-formed citation. Answering without hesitating.</a:t>
+              <a:t>Sounds sure of itself. Smooth, complete sentences. Specific names, dates and numbers. The right work words. Names a source. Answers right away.</a:t>
             </a:r>
             <a:endParaRPr lang="en-US" sz="1600" dirty="0"/>
           </a:p>
@@ -14557,7 +14585,7 @@
                 <a:ea typeface="Calibri" pitchFamily="34" charset="-122"/>
                 <a:cs typeface="Calibri" pitchFamily="34" charset="-120"/>
               </a:rPr>
-              <a:t>WHAT THE MODEL OPTIMIZES FOR</a:t>
+              <a:t>WHAT THE AI IS BUILT TO PRODUCE</a:t>
             </a:r>
             <a:endParaRPr lang="en-US" sz="1050" dirty="0"/>
           </a:p>
@@ -14601,9 +14629,168 @@
                 <a:ea typeface="Calibri" pitchFamily="34" charset="-122"/>
                 <a:cs typeface="Calibri" pitchFamily="34" charset="-120"/>
               </a:rPr>
-              <a:t>Confidence. Fluency. Specific detail. Correct jargon. A well-formed citation. Answering without hesitating.</a:t>
+              <a:t>Sounds sure of itself. Smooth, complete sentences. Specific names, dates and numbers. The right work words. Names a source. Answers right away.</a:t>
             </a:r>
             <a:endParaRPr lang="en-US" sz="1600" dirty="0"/>
+          </a:p>
+        </p:txBody>
+      </p:sp>
+      <p:sp>
+        <p:nvSpPr>
+          <p:cNvPr id="40" name="Plain-language glossary"/>
+          <p:cNvSpPr txBox="1"/>
+          <p:nvPr/>
+        </p:nvSpPr>
+        <p:spPr>
+          <a:xfrm>
+            <a:off x="914400" y="2468880"/>
+            <a:ext cx="10362895" cy="320040"/>
+          </a:xfrm>
+          <a:prstGeom prst="rect">
+            <a:avLst/>
+          </a:prstGeom>
+          <a:noFill/>
+        </p:spPr>
+        <p:txBody>
+          <a:bodyPr wrap="square" lIns="0" tIns="0" rIns="0" bIns="0" rtlCol="0" anchor="ctr">
+            <a:noAutofit/>
+          </a:bodyPr>
+          <a:lstStyle/>
+          <a:p>
+            <a:pPr indent="0" marL="0">
+              <a:buNone/>
+            </a:pPr>
+            <a:r>
+              <a:rPr lang="en-US" sz="1400" b="1" dirty="0">
+                <a:solidFill>
+                  <a:srgbClr val="FFFFFF"/>
+                </a:solidFill>
+                <a:latin typeface="Calibri" pitchFamily="34" charset="0"/>
+                <a:ea typeface="Calibri" pitchFamily="34" charset="-122"/>
+                <a:cs typeface="Calibri" pitchFamily="34" charset="-120"/>
+              </a:rPr>
+              <a:t>Fluency</a:t>
+            </a:r>
+            <a:r>
+              <a:rPr lang="en-US" sz="1400" dirty="0">
+                <a:solidFill>
+                  <a:srgbClr val="9FB0C3"/>
+                </a:solidFill>
+                <a:latin typeface="Calibri" pitchFamily="34" charset="0"/>
+                <a:ea typeface="Calibri" pitchFamily="34" charset="-122"/>
+                <a:cs typeface="Calibri" pitchFamily="34" charset="-120"/>
+              </a:rPr>
+              <a:t xml:space="preserve"> = how it sounds      </a:t>
+            </a:r>
+            <a:r>
+              <a:rPr lang="en-US" sz="1400" b="1" dirty="0">
+                <a:solidFill>
+                  <a:srgbClr val="FFFFFF"/>
+                </a:solidFill>
+                <a:latin typeface="Calibri" pitchFamily="34" charset="0"/>
+                <a:ea typeface="Calibri" pitchFamily="34" charset="-122"/>
+                <a:cs typeface="Calibri" pitchFamily="34" charset="-120"/>
+              </a:rPr>
+              <a:t>Accuracy</a:t>
+            </a:r>
+            <a:r>
+              <a:rPr lang="en-US" sz="1400" dirty="0">
+                <a:solidFill>
+                  <a:srgbClr val="9FB0C3"/>
+                </a:solidFill>
+                <a:latin typeface="Calibri" pitchFamily="34" charset="0"/>
+                <a:ea typeface="Calibri" pitchFamily="34" charset="-122"/>
+                <a:cs typeface="Calibri" pitchFamily="34" charset="-120"/>
+              </a:rPr>
+              <a:t xml:space="preserve"> = whether it's true</a:t>
+            </a:r>
+          </a:p>
+        </p:txBody>
+      </p:sp>
+      <p:sp>
+        <p:nvSpPr>
+          <p:cNvPr id="41" name="See it in action button" descr="Opens the live demo in a browser">
+            <a:hlinkClick r:id="rId3" tooltip="Open the live demo"/>
+          </p:cNvPr>
+          <p:cNvSpPr/>
+          <p:nvPr/>
+        </p:nvSpPr>
+        <p:spPr>
+          <a:xfrm>
+            <a:off x="8580135" y="5669280"/>
+            <a:ext cx="2697160" cy="502920"/>
+          </a:xfrm>
+          <a:prstGeom prst="roundRect">
+            <a:avLst>
+              <a:gd name="adj" fmla="val 50000"/>
+            </a:avLst>
+          </a:prstGeom>
+          <a:solidFill>
+            <a:srgbClr val="FF6600"/>
+          </a:solidFill>
+          <a:ln>
+            <a:noFill/>
+          </a:ln>
+        </p:spPr>
+        <p:txBody>
+          <a:bodyPr wrap="none" lIns="182880" tIns="0" rIns="182880" bIns="0" rtlCol="0" anchor="ctr">
+            <a:noAutofit/>
+          </a:bodyPr>
+          <a:lstStyle/>
+          <a:p>
+            <a:pPr algn="ctr" indent="0" marL="0">
+              <a:buNone/>
+            </a:pPr>
+            <a:r>
+              <a:rPr lang="en-US" sz="1600" b="1" dirty="0">
+                <a:solidFill>
+                  <a:srgbClr val="FFFFFF"/>
+                </a:solidFill>
+                <a:latin typeface="Poppins" pitchFamily="34" charset="0"/>
+                <a:ea typeface="Poppins" pitchFamily="34" charset="-122"/>
+                <a:cs typeface="Poppins" pitchFamily="34" charset="-120"/>
+              </a:rPr>
+              <a:t>See it in action  →</a:t>
+            </a:r>
+          </a:p>
+        </p:txBody>
+      </p:sp>
+      <p:sp>
+        <p:nvSpPr>
+          <p:cNvPr id="42" name="See it in action caption"/>
+          <p:cNvSpPr txBox="1"/>
+          <p:nvPr/>
+        </p:nvSpPr>
+        <p:spPr>
+          <a:xfrm>
+            <a:off x="4937760" y="5669280"/>
+            <a:ext cx="3459480" cy="502920"/>
+          </a:xfrm>
+          <a:prstGeom prst="rect">
+            <a:avLst/>
+          </a:prstGeom>
+          <a:noFill/>
+        </p:spPr>
+        <p:txBody>
+          <a:bodyPr wrap="square" lIns="0" tIns="0" rIns="0" bIns="0" rtlCol="0" anchor="ctr">
+            <a:noAutofit/>
+          </a:bodyPr>
+          <a:lstStyle/>
+          <a:p>
+            <a:pPr algn="r" indent="0" marL="0">
+              <a:buNone/>
+            </a:pPr>
+            <a:r>
+              <a:rPr lang="en-US" sz="1100" dirty="0">
+                <a:solidFill>
+                  <a:srgbClr val="8A9BB0"/>
+                </a:solidFill>
+                <a:latin typeface="Calibri" pitchFamily="34" charset="0"/>
+                <a:ea typeface="Calibri" pitchFamily="34" charset="-122"/>
+                <a:cs typeface="Calibri" pitchFamily="34" charset="-120"/>
+              </a:rPr>
+              <a:t>Four quick steps · about 5 minutes</a:t>
+            </a:r>
           </a:p>
         </p:txBody>
       </p:sp>

</xml_diff>

<commit_message>
Foundations deck: GLBA explainer on slide 22, Sort it yourself button on slide 23
</commit_message>
<xml_diff>
--- a/presentations/files/foundations.pptx
+++ b/presentations/files/foundations.pptx
@@ -1672,9 +1672,8 @@
           <a:p>
             <a:r>
               <a:rPr lang="en-US" dirty="0"/>
-              <a:t/>
-            </a:r>
-            <a:endParaRPr lang="en-US" dirty="0"/>
+              <a:t>GLBA is the Gramm-Leach-Bliley Act. It reaches MCC because the FTC treats institutions that administer Title IV aid as financial institutions. Point at the covers list and ask the financial aid staff which of these they handle every day. Then land the bottom line: FERPA worst case is a letter; GLBA reaches our ability to disburse aid.</a:t>
+            </a:r>
           </a:p>
         </p:txBody>
       </p:sp>
@@ -1761,6 +1760,12 @@
             <a:r>
               <a:rPr lang="en-US" dirty="0"/>
               <a:t>Rebuild this on MCC's own Data Classification vocabulary before teaching it. Using tier names the institution already owns makes adoption dramatically easier.</a:t>
+            </a:r>
+          </a:p>
+          <a:p>
+            <a:r>
+              <a:rPr lang="en-US" dirty="0"/>
+              <a:t>Live game: click Sort it yourself (opens the site in your browser, about 6 minutes). Have the room call each one out loud before you tap. G, Y, R keys answer; right arrow moves on. Cards 2-3 and 6-7 are the lookalike pairs. The last screen has Back to slide; switch back to PowerPoint when done.</a:t>
             </a:r>
             <a:endParaRPr lang="en-US" dirty="0"/>
           </a:p>
@@ -9764,20 +9769,58 @@
       </p:grpSpPr>
       <p:sp>
         <p:nvSpPr>
-          <p:cNvPr id="2" name="Text 0"/>
-          <p:cNvSpPr/>
-          <p:nvPr/>
-        </p:nvSpPr>
-        <p:spPr>
-          <a:xfrm>
-            <a:off x="914400" y="1691640"/>
-            <a:ext cx="9814255" cy="2503424"/>
-          </a:xfrm>
-          <a:prstGeom prst="rect">
-            <a:avLst/>
-          </a:prstGeom>
-          <a:noFill/>
-          <a:ln/>
+          <p:cNvPr id="2" name="Kicker"/>
+          <p:cNvSpPr txBox="1"/>
+          <p:nvPr/>
+        </p:nvSpPr>
+        <p:spPr>
+          <a:xfrm>
+            <a:off x="914400" y="640080"/>
+            <a:ext cx="10362895" cy="274320"/>
+          </a:xfrm>
+          <a:prstGeom prst="rect">
+            <a:avLst/>
+          </a:prstGeom>
+          <a:noFill/>
+        </p:spPr>
+        <p:txBody>
+          <a:bodyPr wrap="square" lIns="0" tIns="0" rIns="0" bIns="0" rtlCol="0" anchor="ctr">
+            <a:normAutofit/>
+          </a:bodyPr>
+          <a:lstStyle/>
+          <a:p>
+            <a:pPr indent="0" marL="0">
+              <a:buNone/>
+            </a:pPr>
+            <a:r>
+              <a:rPr lang="en-US" sz="1150" b="1" spc="260" dirty="0">
+                <a:solidFill>
+                  <a:srgbClr val="FF6600"/>
+                </a:solidFill>
+                <a:latin typeface="Calibri" pitchFamily="34" charset="0"/>
+                <a:ea typeface="Calibri" pitchFamily="34" charset="-122"/>
+                <a:cs typeface="Calibri" pitchFamily="34" charset="-120"/>
+              </a:rPr>
+              <a:t xml:space="preserve">THE ONE WITH TEETH</a:t>
+            </a:r>
+          </a:p>
+        </p:txBody>
+      </p:sp>
+      <p:sp>
+        <p:nvSpPr>
+          <p:cNvPr id="3" name="Title"/>
+          <p:cNvSpPr txBox="1"/>
+          <p:nvPr/>
+        </p:nvSpPr>
+        <p:spPr>
+          <a:xfrm>
+            <a:off x="914400" y="960120"/>
+            <a:ext cx="10362895" cy="685800"/>
+          </a:xfrm>
+          <a:prstGeom prst="rect">
+            <a:avLst/>
+          </a:prstGeom>
+          <a:noFill/>
         </p:spPr>
         <p:txBody>
           <a:bodyPr wrap="square" lIns="0" tIns="0" rIns="0" bIns="0" rtlCol="0" anchor="t">
@@ -9786,33 +9829,21 @@
           <a:lstStyle/>
           <a:p>
             <a:pPr indent="0" marL="0">
-              <a:lnSpc>
-                <a:spcPts val="4640"/>
-              </a:lnSpc>
-              <a:buNone/>
-            </a:pPr>
-            <a:r>
-              <a:rPr lang="en-US" sz="4000" b="1" dirty="0">
-                <a:solidFill>
-                  <a:srgbClr val="FFFFFF"/>
+              <a:buNone/>
+            </a:pPr>
+            <a:r>
+              <a:rPr lang="en-US" sz="3600" b="1" dirty="0">
+                <a:solidFill>
+                  <a:srgbClr val="FF6600"/>
                 </a:solidFill>
                 <a:latin typeface="Poppins" pitchFamily="34" charset="0"/>
                 <a:ea typeface="Poppins" pitchFamily="34" charset="-122"/>
                 <a:cs typeface="Poppins" pitchFamily="34" charset="-120"/>
               </a:rPr>
-              <a:t>FERPA's worst case</a:t>
-            </a:r>
-            <a:endParaRPr lang="en-US" sz="4000" dirty="0"/>
-          </a:p>
-          <a:p>
-            <a:pPr indent="0" marL="0">
-              <a:lnSpc>
-                <a:spcPts val="4640"/>
-              </a:lnSpc>
-              <a:buNone/>
-            </a:pPr>
-            <a:r>
-              <a:rPr lang="en-US" sz="4000" b="1" dirty="0">
+              <a:t xml:space="preserve">GLBA</a:t>
+            </a:r>
+            <a:r>
+              <a:rPr lang="en-US" sz="3600" b="1" dirty="0">
                 <a:solidFill>
                   <a:srgbClr val="FFFFFF"/>
                 </a:solidFill>
@@ -9820,19 +9851,533 @@
                 <a:ea typeface="Poppins" pitchFamily="34" charset="-122"/>
                 <a:cs typeface="Poppins" pitchFamily="34" charset="-120"/>
               </a:rPr>
-              <a:t>is a letter.</a:t>
-            </a:r>
-            <a:endParaRPr lang="en-US" sz="4000" dirty="0"/>
-          </a:p>
-          <a:p>
-            <a:pPr indent="0" marL="0">
-              <a:lnSpc>
-                <a:spcPts val="4640"/>
-              </a:lnSpc>
-              <a:buNone/>
-            </a:pPr>
-            <a:r>
-              <a:rPr lang="en-US" sz="4000" b="1" dirty="0">
+              <a:t xml:space="preserve">: the Gramm-Leach-Bliley Act</a:t>
+            </a:r>
+          </a:p>
+        </p:txBody>
+      </p:sp>
+      <p:sp>
+        <p:nvSpPr>
+          <p:cNvPr id="4" name="Lede"/>
+          <p:cNvSpPr txBox="1"/>
+          <p:nvPr/>
+        </p:nvSpPr>
+        <p:spPr>
+          <a:xfrm>
+            <a:off x="914400" y="1737360"/>
+            <a:ext cx="9601200" cy="640080"/>
+          </a:xfrm>
+          <a:prstGeom prst="rect">
+            <a:avLst/>
+          </a:prstGeom>
+          <a:noFill/>
+        </p:spPr>
+        <p:txBody>
+          <a:bodyPr wrap="square" lIns="0" tIns="0" rIns="0" bIns="0" rtlCol="0" anchor="t">
+            <a:normAutofit/>
+          </a:bodyPr>
+          <a:lstStyle/>
+          <a:p>
+            <a:pPr indent="0" marL="0">
+              <a:lnSpc>
+                <a:spcPct val="110000"/>
+              </a:lnSpc>
+              <a:buNone/>
+            </a:pPr>
+            <a:r>
+              <a:rPr lang="en-US" sz="1800" dirty="0">
+                <a:solidFill>
+                  <a:srgbClr val="B4C2D2"/>
+                </a:solidFill>
+                <a:latin typeface="Calibri" pitchFamily="34" charset="0"/>
+                <a:ea typeface="Calibri" pitchFamily="34" charset="-122"/>
+                <a:cs typeface="Calibri" pitchFamily="34" charset="-120"/>
+              </a:rPr>
+              <a:t xml:space="preserve">A federal law from 1999 that protects people's </a:t>
+            </a:r>
+            <a:r>
+              <a:rPr lang="en-US" sz="1800" b="1" dirty="0">
+                <a:solidFill>
+                  <a:srgbClr val="FFFFFF"/>
+                </a:solidFill>
+                <a:latin typeface="Calibri" pitchFamily="34" charset="0"/>
+                <a:ea typeface="Calibri" pitchFamily="34" charset="-122"/>
+                <a:cs typeface="Calibri" pitchFamily="34" charset="-120"/>
+              </a:rPr>
+              <a:t xml:space="preserve">financial information</a:t>
+            </a:r>
+            <a:r>
+              <a:rPr lang="en-US" sz="1800" dirty="0">
+                <a:solidFill>
+                  <a:srgbClr val="B4C2D2"/>
+                </a:solidFill>
+                <a:latin typeface="Calibri" pitchFamily="34" charset="0"/>
+                <a:ea typeface="Calibri" pitchFamily="34" charset="-122"/>
+                <a:cs typeface="Calibri" pitchFamily="34" charset="-120"/>
+              </a:rPr>
+              <a:t xml:space="preserve">. It applies to MCC because we handle </a:t>
+            </a:r>
+            <a:r>
+              <a:rPr lang="en-US" sz="1800" b="1" dirty="0">
+                <a:solidFill>
+                  <a:srgbClr val="FFFFFF"/>
+                </a:solidFill>
+                <a:latin typeface="Calibri" pitchFamily="34" charset="0"/>
+                <a:ea typeface="Calibri" pitchFamily="34" charset="-122"/>
+                <a:cs typeface="Calibri" pitchFamily="34" charset="-120"/>
+              </a:rPr>
+              <a:t xml:space="preserve">federal student aid</a:t>
+            </a:r>
+            <a:r>
+              <a:rPr lang="en-US" sz="1800" dirty="0">
+                <a:solidFill>
+                  <a:srgbClr val="B4C2D2"/>
+                </a:solidFill>
+                <a:latin typeface="Calibri" pitchFamily="34" charset="0"/>
+                <a:ea typeface="Calibri" pitchFamily="34" charset="-122"/>
+                <a:cs typeface="Calibri" pitchFamily="34" charset="-120"/>
+              </a:rPr>
+              <a:t xml:space="preserve">.</a:t>
+            </a:r>
+          </a:p>
+        </p:txBody>
+      </p:sp>
+      <p:sp>
+        <p:nvSpPr>
+          <p:cNvPr id="5" name="Panel: what it covers"/>
+          <p:cNvSpPr/>
+          <p:nvPr/>
+        </p:nvSpPr>
+        <p:spPr>
+          <a:xfrm>
+            <a:off x="914400" y="2468880"/>
+            <a:ext cx="3271418" cy="2240280"/>
+          </a:xfrm>
+          <a:prstGeom prst="roundRect">
+            <a:avLst>
+              <a:gd name="adj" fmla="val 6000"/>
+            </a:avLst>
+          </a:prstGeom>
+          <a:solidFill>
+            <a:srgbClr val="12263E"/>
+          </a:solidFill>
+          <a:ln>
+            <a:noFill/>
+          </a:ln>
+        </p:spPr>
+        <p:txBody>
+          <a:bodyPr wrap="square" lIns="182880" tIns="182880" rIns="182880" bIns="182880" rtlCol="0" anchor="t">
+            <a:normAutofit/>
+          </a:bodyPr>
+          <a:lstStyle/>
+          <a:p>
+            <a:pPr indent="0" marL="0">
+              <a:spcAft>
+                <a:spcPts val="600"/>
+              </a:spcAft>
+              <a:buNone/>
+            </a:pPr>
+            <a:r>
+              <a:rPr lang="en-US" sz="1050" b="1" spc="200" dirty="0">
+                <a:solidFill>
+                  <a:srgbClr val="1FB3CC"/>
+                </a:solidFill>
+                <a:latin typeface="Calibri" pitchFamily="34" charset="0"/>
+                <a:ea typeface="Calibri" pitchFamily="34" charset="-122"/>
+                <a:cs typeface="Calibri" pitchFamily="34" charset="-120"/>
+              </a:rPr>
+              <a:t xml:space="preserve">WHAT IT COVERS</a:t>
+            </a:r>
+          </a:p>
+          <a:p>
+            <a:pPr marL="182880" indent="-182880">
+              <a:spcAft>
+                <a:spcPts val="200"/>
+              </a:spcAft>
+              <a:buFont typeface="Arial"/>
+              <a:buChar char="•"/>
+            </a:pPr>
+            <a:r>
+              <a:rPr lang="en-US" sz="1300" dirty="0">
+                <a:solidFill>
+                  <a:srgbClr val="B4C2D2"/>
+                </a:solidFill>
+                <a:latin typeface="Calibri" pitchFamily="34" charset="0"/>
+                <a:ea typeface="Calibri" pitchFamily="34" charset="-122"/>
+                <a:cs typeface="Calibri" pitchFamily="34" charset="-120"/>
+              </a:rPr>
+              <a:t xml:space="preserve">FAFSA data and ISIRs</a:t>
+            </a:r>
+          </a:p>
+          <a:p>
+            <a:pPr marL="182880" indent="-182880">
+              <a:spcAft>
+                <a:spcPts val="200"/>
+              </a:spcAft>
+              <a:buFont typeface="Arial"/>
+              <a:buChar char="•"/>
+            </a:pPr>
+            <a:r>
+              <a:rPr lang="en-US" sz="1300" dirty="0">
+                <a:solidFill>
+                  <a:srgbClr val="B4C2D2"/>
+                </a:solidFill>
+                <a:latin typeface="Calibri" pitchFamily="34" charset="0"/>
+                <a:ea typeface="Calibri" pitchFamily="34" charset="-122"/>
+                <a:cs typeface="Calibri" pitchFamily="34" charset="-120"/>
+              </a:rPr>
+              <a:t xml:space="preserve">Tax and income information</a:t>
+            </a:r>
+          </a:p>
+          <a:p>
+            <a:pPr marL="182880" indent="-182880">
+              <a:spcAft>
+                <a:spcPts val="200"/>
+              </a:spcAft>
+              <a:buFont typeface="Arial"/>
+              <a:buChar char="•"/>
+            </a:pPr>
+            <a:r>
+              <a:rPr lang="en-US" sz="1300" dirty="0">
+                <a:solidFill>
+                  <a:srgbClr val="B4C2D2"/>
+                </a:solidFill>
+                <a:latin typeface="Calibri" pitchFamily="34" charset="0"/>
+                <a:ea typeface="Calibri" pitchFamily="34" charset="-122"/>
+                <a:cs typeface="Calibri" pitchFamily="34" charset="-120"/>
+              </a:rPr>
+              <a:t xml:space="preserve">Social Security numbers</a:t>
+            </a:r>
+          </a:p>
+          <a:p>
+            <a:pPr marL="182880" indent="-182880">
+              <a:spcAft>
+                <a:spcPts val="200"/>
+              </a:spcAft>
+              <a:buFont typeface="Arial"/>
+              <a:buChar char="•"/>
+            </a:pPr>
+            <a:r>
+              <a:rPr lang="en-US" sz="1300" dirty="0">
+                <a:solidFill>
+                  <a:srgbClr val="B4C2D2"/>
+                </a:solidFill>
+                <a:latin typeface="Calibri" pitchFamily="34" charset="0"/>
+                <a:ea typeface="Calibri" pitchFamily="34" charset="-122"/>
+                <a:cs typeface="Calibri" pitchFamily="34" charset="-120"/>
+              </a:rPr>
+              <a:t xml:space="preserve">Bank and routing numbers</a:t>
+            </a:r>
+          </a:p>
+          <a:p>
+            <a:pPr marL="182880" indent="-182880">
+              <a:spcAft>
+                <a:spcPts val="200"/>
+              </a:spcAft>
+              <a:buFont typeface="Arial"/>
+              <a:buChar char="•"/>
+            </a:pPr>
+            <a:r>
+              <a:rPr lang="en-US" sz="1300" dirty="0">
+                <a:solidFill>
+                  <a:srgbClr val="B4C2D2"/>
+                </a:solidFill>
+                <a:latin typeface="Calibri" pitchFamily="34" charset="0"/>
+                <a:ea typeface="Calibri" pitchFamily="34" charset="-122"/>
+                <a:cs typeface="Calibri" pitchFamily="34" charset="-120"/>
+              </a:rPr>
+              <a:t xml:space="preserve">Verification documents</a:t>
+            </a:r>
+          </a:p>
+          <a:p>
+            <a:pPr marL="182880" indent="-182880">
+              <a:spcAft>
+                <a:spcPts val="200"/>
+              </a:spcAft>
+              <a:buFont typeface="Arial"/>
+              <a:buChar char="•"/>
+            </a:pPr>
+            <a:r>
+              <a:rPr lang="en-US" sz="1300" dirty="0">
+                <a:solidFill>
+                  <a:srgbClr val="B4C2D2"/>
+                </a:solidFill>
+                <a:latin typeface="Calibri" pitchFamily="34" charset="0"/>
+                <a:ea typeface="Calibri" pitchFamily="34" charset="-122"/>
+                <a:cs typeface="Calibri" pitchFamily="34" charset="-120"/>
+              </a:rPr>
+              <a:t xml:space="preserve">Hardship stories in aid appeals</a:t>
+            </a:r>
+          </a:p>
+        </p:txBody>
+      </p:sp>
+      <p:sp>
+        <p:nvSpPr>
+          <p:cNvPr id="6" name="Panel: what it requires"/>
+          <p:cNvSpPr/>
+          <p:nvPr/>
+        </p:nvSpPr>
+        <p:spPr>
+          <a:xfrm>
+            <a:off x="4460138" y="2468880"/>
+            <a:ext cx="3271418" cy="2240280"/>
+          </a:xfrm>
+          <a:prstGeom prst="roundRect">
+            <a:avLst>
+              <a:gd name="adj" fmla="val 6000"/>
+            </a:avLst>
+          </a:prstGeom>
+          <a:solidFill>
+            <a:srgbClr val="12263E"/>
+          </a:solidFill>
+          <a:ln>
+            <a:noFill/>
+          </a:ln>
+        </p:spPr>
+        <p:txBody>
+          <a:bodyPr wrap="square" lIns="182880" tIns="182880" rIns="182880" bIns="182880" rtlCol="0" anchor="t">
+            <a:normAutofit/>
+          </a:bodyPr>
+          <a:lstStyle/>
+          <a:p>
+            <a:pPr indent="0" marL="0">
+              <a:spcAft>
+                <a:spcPts val="600"/>
+              </a:spcAft>
+              <a:buNone/>
+            </a:pPr>
+            <a:r>
+              <a:rPr lang="en-US" sz="1050" b="1" spc="200" dirty="0">
+                <a:solidFill>
+                  <a:srgbClr val="1FB3CC"/>
+                </a:solidFill>
+                <a:latin typeface="Calibri" pitchFamily="34" charset="0"/>
+                <a:ea typeface="Calibri" pitchFamily="34" charset="-122"/>
+                <a:cs typeface="Calibri" pitchFamily="34" charset="-120"/>
+              </a:rPr>
+              <a:t xml:space="preserve">WHAT IT REQUIRES</a:t>
+            </a:r>
+          </a:p>
+          <a:p>
+            <a:pPr indent="0" marL="0">
+              <a:lnSpc>
+                <a:spcPct val="110000"/>
+              </a:lnSpc>
+              <a:spcAft>
+                <a:spcPts val="900"/>
+              </a:spcAft>
+              <a:buNone/>
+            </a:pPr>
+            <a:r>
+              <a:rPr lang="en-US" sz="1400" dirty="0">
+                <a:solidFill>
+                  <a:srgbClr val="B4C2D2"/>
+                </a:solidFill>
+                <a:latin typeface="Calibri" pitchFamily="34" charset="0"/>
+                <a:ea typeface="Calibri" pitchFamily="34" charset="-122"/>
+                <a:cs typeface="Calibri" pitchFamily="34" charset="-120"/>
+              </a:rPr>
+              <a:t xml:space="preserve">A </a:t>
+            </a:r>
+            <a:r>
+              <a:rPr lang="en-US" sz="1400" b="1" dirty="0">
+                <a:solidFill>
+                  <a:srgbClr val="FFFFFF"/>
+                </a:solidFill>
+                <a:latin typeface="Calibri" pitchFamily="34" charset="0"/>
+                <a:ea typeface="Calibri" pitchFamily="34" charset="-122"/>
+                <a:cs typeface="Calibri" pitchFamily="34" charset="-120"/>
+              </a:rPr>
+              <a:t xml:space="preserve">written security program</a:t>
+            </a:r>
+            <a:r>
+              <a:rPr lang="en-US" sz="1400" dirty="0">
+                <a:solidFill>
+                  <a:srgbClr val="B4C2D2"/>
+                </a:solidFill>
+                <a:latin typeface="Calibri" pitchFamily="34" charset="0"/>
+                <a:ea typeface="Calibri" pitchFamily="34" charset="-122"/>
+                <a:cs typeface="Calibri" pitchFamily="34" charset="-120"/>
+              </a:rPr>
+              <a:t xml:space="preserve"> for that information, and </a:t>
+            </a:r>
+            <a:r>
+              <a:rPr lang="en-US" sz="1400" b="1" dirty="0">
+                <a:solidFill>
+                  <a:srgbClr val="FFFFFF"/>
+                </a:solidFill>
+                <a:latin typeface="Calibri" pitchFamily="34" charset="0"/>
+                <a:ea typeface="Calibri" pitchFamily="34" charset="-122"/>
+                <a:cs typeface="Calibri" pitchFamily="34" charset="-120"/>
+              </a:rPr>
+              <a:t xml:space="preserve">oversight of every outside company</a:t>
+            </a:r>
+            <a:r>
+              <a:rPr lang="en-US" sz="1400" dirty="0">
+                <a:solidFill>
+                  <a:srgbClr val="B4C2D2"/>
+                </a:solidFill>
+                <a:latin typeface="Calibri" pitchFamily="34" charset="0"/>
+                <a:ea typeface="Calibri" pitchFamily="34" charset="-122"/>
+                <a:cs typeface="Calibri" pitchFamily="34" charset="-120"/>
+              </a:rPr>
+              <a:t xml:space="preserve"> that handles it.</a:t>
+            </a:r>
+          </a:p>
+          <a:p>
+            <a:pPr indent="0" marL="0">
+              <a:buNone/>
+            </a:pPr>
+            <a:r>
+              <a:rPr lang="en-US" sz="1000" dirty="0">
+                <a:solidFill>
+                  <a:srgbClr val="7F92A8"/>
+                </a:solidFill>
+                <a:latin typeface="Calibri" pitchFamily="34" charset="0"/>
+                <a:ea typeface="Calibri" pitchFamily="34" charset="-122"/>
+                <a:cs typeface="Calibri" pitchFamily="34" charset="-120"/>
+              </a:rPr>
+              <a:t xml:space="preserve">FTC Safeguards Rule, 16 CFR Part 314 · updated rule fully enforceable since June 9, 2023</a:t>
+            </a:r>
+          </a:p>
+        </p:txBody>
+      </p:sp>
+      <p:sp>
+        <p:nvSpPr>
+          <p:cNvPr id="7" name="Panel: where AI comes in"/>
+          <p:cNvSpPr/>
+          <p:nvPr/>
+        </p:nvSpPr>
+        <p:spPr>
+          <a:xfrm>
+            <a:off x="8005876" y="2468880"/>
+            <a:ext cx="3271418" cy="2240280"/>
+          </a:xfrm>
+          <a:prstGeom prst="roundRect">
+            <a:avLst>
+              <a:gd name="adj" fmla="val 6000"/>
+            </a:avLst>
+          </a:prstGeom>
+          <a:solidFill>
+            <a:srgbClr val="12263E"/>
+          </a:solidFill>
+          <a:ln>
+            <a:noFill/>
+          </a:ln>
+        </p:spPr>
+        <p:txBody>
+          <a:bodyPr wrap="square" lIns="182880" tIns="182880" rIns="182880" bIns="182880" rtlCol="0" anchor="t">
+            <a:normAutofit/>
+          </a:bodyPr>
+          <a:lstStyle/>
+          <a:p>
+            <a:pPr indent="0" marL="0">
+              <a:spcAft>
+                <a:spcPts val="600"/>
+              </a:spcAft>
+              <a:buNone/>
+            </a:pPr>
+            <a:r>
+              <a:rPr lang="en-US" sz="1050" b="1" spc="200" dirty="0">
+                <a:solidFill>
+                  <a:srgbClr val="1FB3CC"/>
+                </a:solidFill>
+                <a:latin typeface="Calibri" pitchFamily="34" charset="0"/>
+                <a:ea typeface="Calibri" pitchFamily="34" charset="-122"/>
+                <a:cs typeface="Calibri" pitchFamily="34" charset="-120"/>
+              </a:rPr>
+              <a:t xml:space="preserve">WHERE AI COMES IN</a:t>
+            </a:r>
+          </a:p>
+          <a:p>
+            <a:pPr indent="0" marL="0">
+              <a:lnSpc>
+                <a:spcPct val="110000"/>
+              </a:lnSpc>
+              <a:buNone/>
+            </a:pPr>
+            <a:r>
+              <a:rPr lang="en-US" sz="1400" dirty="0">
+                <a:solidFill>
+                  <a:srgbClr val="B4C2D2"/>
+                </a:solidFill>
+                <a:latin typeface="Calibri" pitchFamily="34" charset="0"/>
+                <a:ea typeface="Calibri" pitchFamily="34" charset="-122"/>
+                <a:cs typeface="Calibri" pitchFamily="34" charset="-120"/>
+              </a:rPr>
+              <a:t xml:space="preserve">Pasting an ISIR into a free chatbot hands aid data to a company </a:t>
+            </a:r>
+            <a:r>
+              <a:rPr lang="en-US" sz="1400" b="1" dirty="0">
+                <a:solidFill>
+                  <a:srgbClr val="FFFFFF"/>
+                </a:solidFill>
+                <a:latin typeface="Calibri" pitchFamily="34" charset="0"/>
+                <a:ea typeface="Calibri" pitchFamily="34" charset="-122"/>
+                <a:cs typeface="Calibri" pitchFamily="34" charset="-120"/>
+              </a:rPr>
+              <a:t xml:space="preserve">MCC never vetted</a:t>
+            </a:r>
+            <a:r>
+              <a:rPr lang="en-US" sz="1400" dirty="0">
+                <a:solidFill>
+                  <a:srgbClr val="B4C2D2"/>
+                </a:solidFill>
+                <a:latin typeface="Calibri" pitchFamily="34" charset="0"/>
+                <a:ea typeface="Calibri" pitchFamily="34" charset="-122"/>
+                <a:cs typeface="Calibri" pitchFamily="34" charset="-120"/>
+              </a:rPr>
+              <a:t xml:space="preserve">. That skips the oversight the rule requires.</a:t>
+            </a:r>
+          </a:p>
+        </p:txBody>
+      </p:sp>
+      <p:sp>
+        <p:nvSpPr>
+          <p:cNvPr id="8" name="FERPA worst case"/>
+          <p:cNvSpPr txBox="1"/>
+          <p:nvPr/>
+        </p:nvSpPr>
+        <p:spPr>
+          <a:xfrm>
+            <a:off x="914400" y="4937760"/>
+            <a:ext cx="4998567" cy="868680"/>
+          </a:xfrm>
+          <a:prstGeom prst="rect">
+            <a:avLst/>
+          </a:prstGeom>
+          <a:noFill/>
+        </p:spPr>
+        <p:txBody>
+          <a:bodyPr wrap="square" lIns="0" tIns="0" rIns="0" bIns="0" rtlCol="0" anchor="t">
+            <a:normAutofit/>
+          </a:bodyPr>
+          <a:lstStyle/>
+          <a:p>
+            <a:pPr indent="0" marL="0">
+              <a:spcAft>
+                <a:spcPts val="400"/>
+              </a:spcAft>
+              <a:buNone/>
+            </a:pPr>
+            <a:r>
+              <a:rPr lang="en-US" sz="1000" b="1" spc="150" dirty="0">
+                <a:solidFill>
+                  <a:srgbClr val="7F92A8"/>
+                </a:solidFill>
+                <a:latin typeface="Calibri" pitchFamily="34" charset="0"/>
+                <a:ea typeface="Calibri" pitchFamily="34" charset="-122"/>
+                <a:cs typeface="Calibri" pitchFamily="34" charset="-120"/>
+              </a:rPr>
+              <a:t xml:space="preserve">FERPA · STUDENT RECORDS</a:t>
+            </a:r>
+          </a:p>
+          <a:p>
+            <a:pPr indent="0" marL="0">
+              <a:buNone/>
+            </a:pPr>
+            <a:r>
+              <a:rPr lang="en-US" sz="1800" b="1" dirty="0">
                 <a:solidFill>
                   <a:srgbClr val="FFFFFF"/>
                 </a:solidFill>
@@ -9840,29 +10385,66 @@
                 <a:ea typeface="Poppins" pitchFamily="34" charset="-122"/>
                 <a:cs typeface="Poppins" pitchFamily="34" charset="-120"/>
               </a:rPr>
-              <a:t>GLBA's reaches our</a:t>
-            </a:r>
-            <a:endParaRPr lang="en-US" sz="4000" dirty="0"/>
-          </a:p>
-          <a:p>
-            <a:pPr indent="0" marL="0">
-              <a:lnSpc>
-                <a:spcPts val="4640"/>
-              </a:lnSpc>
-              <a:buNone/>
-            </a:pPr>
-            <a:r>
-              <a:rPr lang="en-US" sz="4000" b="1" dirty="0">
-                <a:solidFill>
-                  <a:srgbClr val="FFFFFF"/>
+              <a:t xml:space="preserve">Worst case: a letter from the Department of Education.</a:t>
+            </a:r>
+          </a:p>
+        </p:txBody>
+      </p:sp>
+      <p:sp>
+        <p:nvSpPr>
+          <p:cNvPr id="9" name="GLBA worst case"/>
+          <p:cNvSpPr txBox="1"/>
+          <p:nvPr/>
+        </p:nvSpPr>
+        <p:spPr>
+          <a:xfrm>
+            <a:off x="6278727" y="4937760"/>
+            <a:ext cx="4998567" cy="868680"/>
+          </a:xfrm>
+          <a:prstGeom prst="rect">
+            <a:avLst/>
+          </a:prstGeom>
+          <a:noFill/>
+        </p:spPr>
+        <p:txBody>
+          <a:bodyPr wrap="square" lIns="0" tIns="0" rIns="0" bIns="0" rtlCol="0" anchor="t">
+            <a:normAutofit/>
+          </a:bodyPr>
+          <a:lstStyle/>
+          <a:p>
+            <a:pPr indent="0" marL="0">
+              <a:spcAft>
+                <a:spcPts val="400"/>
+              </a:spcAft>
+              <a:buNone/>
+            </a:pPr>
+            <a:r>
+              <a:rPr lang="en-US" sz="1000" b="1" spc="150" dirty="0">
+                <a:solidFill>
+                  <a:srgbClr val="7F92A8"/>
+                </a:solidFill>
+                <a:latin typeface="Calibri" pitchFamily="34" charset="0"/>
+                <a:ea typeface="Calibri" pitchFamily="34" charset="-122"/>
+                <a:cs typeface="Calibri" pitchFamily="34" charset="-120"/>
+              </a:rPr>
+              <a:t xml:space="preserve">GLBA · FINANCIAL AID DATA</a:t>
+            </a:r>
+          </a:p>
+          <a:p>
+            <a:pPr indent="0" marL="0">
+              <a:buNone/>
+            </a:pPr>
+            <a:r>
+              <a:rPr lang="en-US" sz="1800" b="1" dirty="0">
+                <a:solidFill>
+                  <a:srgbClr val="FF6600"/>
                 </a:solidFill>
                 <a:latin typeface="Poppins" pitchFamily="34" charset="0"/>
                 <a:ea typeface="Poppins" pitchFamily="34" charset="-122"/>
                 <a:cs typeface="Poppins" pitchFamily="34" charset="-120"/>
               </a:rPr>
-              <a:t>ability to disburse aid.</a:t>
-            </a:r>
-            <a:endParaRPr lang="en-US" sz="4000" dirty="0"/>
+              <a:t xml:space="preserve">Worst case: our ability to give students financial aid.</a:t>
+            </a:r>
           </a:p>
         </p:txBody>
       </p:sp>
@@ -10420,7 +11002,7 @@
         <p:spPr>
           <a:xfrm>
             <a:off x="914400" y="5532120"/>
-            <a:ext cx="10362895" cy="384048"/>
+            <a:ext cx="4572000" cy="384048"/>
           </a:xfrm>
           <a:prstGeom prst="rect">
             <a:avLst/>
@@ -10449,6 +11031,93 @@
               <a:t>When in doubt, it is red.</a:t>
             </a:r>
             <a:endParaRPr lang="en-US" sz="2000" dirty="0"/>
+          </a:p>
+        </p:txBody>
+      </p:sp>
+      <p:sp>
+        <p:nvSpPr>
+          <p:cNvPr id="41" name="Sort it yourself button" descr="Opens the sorting game in a browser">
+            <a:hlinkClick r:id="rId3" tooltip="Open the sorting game"/>
+          </p:cNvPr>
+          <p:cNvSpPr/>
+          <p:nvPr/>
+        </p:nvSpPr>
+        <p:spPr>
+          <a:xfrm>
+            <a:off x="8580135" y="5472684"/>
+            <a:ext cx="2697160" cy="502920"/>
+          </a:xfrm>
+          <a:prstGeom prst="roundRect">
+            <a:avLst>
+              <a:gd name="adj" fmla="val 50000"/>
+            </a:avLst>
+          </a:prstGeom>
+          <a:solidFill>
+            <a:srgbClr val="FF6600"/>
+          </a:solidFill>
+          <a:ln>
+            <a:noFill/>
+          </a:ln>
+        </p:spPr>
+        <p:txBody>
+          <a:bodyPr wrap="none" lIns="182880" tIns="0" rIns="182880" bIns="0" rtlCol="0" anchor="ctr">
+            <a:noAutofit/>
+          </a:bodyPr>
+          <a:lstStyle/>
+          <a:p>
+            <a:pPr algn="ctr" indent="0" marL="0">
+              <a:buNone/>
+            </a:pPr>
+            <a:r>
+              <a:rPr lang="en-US" sz="1600" b="1" dirty="0">
+                <a:solidFill>
+                  <a:srgbClr val="FFFFFF"/>
+                </a:solidFill>
+                <a:latin typeface="Poppins" pitchFamily="34" charset="0"/>
+                <a:ea typeface="Poppins" pitchFamily="34" charset="-122"/>
+                <a:cs typeface="Poppins" pitchFamily="34" charset="-120"/>
+              </a:rPr>
+              <a:t xml:space="preserve">Sort it yourself  →</a:t>
+            </a:r>
+          </a:p>
+        </p:txBody>
+      </p:sp>
+      <p:sp>
+        <p:nvSpPr>
+          <p:cNvPr id="42" name="Sort it yourself caption"/>
+          <p:cNvSpPr txBox="1"/>
+          <p:nvPr/>
+        </p:nvSpPr>
+        <p:spPr>
+          <a:xfrm>
+            <a:off x="4937760" y="5472684"/>
+            <a:ext cx="3459480" cy="502920"/>
+          </a:xfrm>
+          <a:prstGeom prst="rect">
+            <a:avLst/>
+          </a:prstGeom>
+          <a:noFill/>
+        </p:spPr>
+        <p:txBody>
+          <a:bodyPr wrap="square" lIns="0" tIns="0" rIns="0" bIns="0" rtlCol="0" anchor="ctr">
+            <a:normAutofit/>
+          </a:bodyPr>
+          <a:lstStyle/>
+          <a:p>
+            <a:pPr algn="r" indent="0" marL="0">
+              <a:buNone/>
+            </a:pPr>
+            <a:r>
+              <a:rPr lang="en-US" sz="1100" dirty="0">
+                <a:solidFill>
+                  <a:srgbClr val="8A939E"/>
+                </a:solidFill>
+                <a:latin typeface="Calibri" pitchFamily="34" charset="0"/>
+                <a:ea typeface="Calibri" pitchFamily="34" charset="-122"/>
+                <a:cs typeface="Calibri" pitchFamily="34" charset="-120"/>
+              </a:rPr>
+              <a:t xml:space="preserve">12 real situations · about 6 minutes</a:t>
+            </a:r>
           </a:p>
         </p:txBody>
       </p:sp>

</xml_diff>

<commit_message>
Foundations deck: five-part agenda on slide 2
</commit_message>
<xml_diff>
--- a/presentations/files/foundations.pptx
+++ b/presentations/files/foundations.pptx
@@ -1497,6 +1497,12 @@
             <a:r>
               <a:rPr lang="en-US" dirty="0"/>
               <a:t>Say this out loud in the first two minutes. It is the difference between a room that engages and a room that waits you out.</a:t>
+            </a:r>
+          </a:p>
+          <a:p>
+            <a:r>
+              <a:rPr lang="en-US" dirty="0"/>
+              <a:t>Then walk the five items. 1 is Part One (slides 4-10). 2 is slides 11-14. 3 is Part Two (15-19). 4 is Part Three (20-23). 5 is slides 24-26.</a:t>
             </a:r>
             <a:endParaRPr lang="en-US" dirty="0"/>
           </a:p>
@@ -8791,8 +8797,8 @@
         </p:nvSpPr>
         <p:spPr>
           <a:xfrm>
-            <a:off x="914400" y="1965960"/>
-            <a:ext cx="9814255" cy="1678432"/>
+            <a:off x="914400" y="1920240"/>
+            <a:ext cx="4480560" cy="1188720"/>
           </a:xfrm>
           <a:prstGeom prst="rect">
             <a:avLst/>
@@ -8808,12 +8814,12 @@
           <a:p>
             <a:pPr indent="0" marL="0">
               <a:lnSpc>
-                <a:spcPts val="6032"/>
-              </a:lnSpc>
-              <a:buNone/>
-            </a:pPr>
-            <a:r>
-              <a:rPr lang="en-US" sz="5200" b="1" dirty="0">
+                <a:spcPts val="4200"/>
+              </a:lnSpc>
+              <a:buNone/>
+            </a:pPr>
+            <a:r>
+              <a:rPr lang="en-US" sz="3600" b="1" dirty="0">
                 <a:solidFill>
                   <a:srgbClr val="FFFFFF"/>
                 </a:solidFill>
@@ -8823,17 +8829,17 @@
               </a:rPr>
               <a:t>Nobody here is</a:t>
             </a:r>
-            <a:endParaRPr lang="en-US" sz="5200" dirty="0"/>
-          </a:p>
-          <a:p>
-            <a:pPr indent="0" marL="0">
-              <a:lnSpc>
-                <a:spcPts val="6032"/>
-              </a:lnSpc>
-              <a:buNone/>
-            </a:pPr>
-            <a:r>
-              <a:rPr lang="en-US" sz="5200" b="1" dirty="0">
+            <a:endParaRPr lang="en-US" sz="3600" dirty="0"/>
+          </a:p>
+          <a:p>
+            <a:pPr indent="0" marL="0">
+              <a:lnSpc>
+                <a:spcPts val="4200"/>
+              </a:lnSpc>
+              <a:buNone/>
+            </a:pPr>
+            <a:r>
+              <a:rPr lang="en-US" sz="3600" b="1" dirty="0">
                 <a:solidFill>
                   <a:srgbClr val="FFFFFF"/>
                 </a:solidFill>
@@ -8843,7 +8849,7 @@
               </a:rPr>
               <a:t>starting from zero.</a:t>
             </a:r>
-            <a:endParaRPr lang="en-US" sz="5200" dirty="0"/>
+            <a:endParaRPr lang="en-US" sz="3600" dirty="0"/>
           </a:p>
         </p:txBody>
       </p:sp>
@@ -8855,8 +8861,8 @@
         </p:nvSpPr>
         <p:spPr>
           <a:xfrm>
-            <a:off x="914400" y="3955288"/>
-            <a:ext cx="8716975" cy="2034032"/>
+            <a:off x="914400" y="3291840"/>
+            <a:ext cx="4480560" cy="1463040"/>
           </a:xfrm>
           <a:prstGeom prst="rect">
             <a:avLst/>
@@ -8872,12 +8878,12 @@
           <a:p>
             <a:pPr indent="0" marL="0">
               <a:lnSpc>
-                <a:spcPts val="3000"/>
-              </a:lnSpc>
-              <a:buNone/>
-            </a:pPr>
-            <a:r>
-              <a:rPr lang="en-US" sz="2000" dirty="0">
+                <a:spcPts val="2600"/>
+              </a:lnSpc>
+              <a:buNone/>
+            </a:pPr>
+            <a:r>
+              <a:rPr lang="en-US" sz="1700" dirty="0">
                 <a:solidFill>
                   <a:srgbClr val="A7B7C9"/>
                 </a:solidFill>
@@ -8885,9 +8891,579 @@
                 <a:ea typeface="Calibri" pitchFamily="34" charset="-122"/>
                 <a:cs typeface="Calibri" pitchFamily="34" charset="-120"/>
               </a:rPr>
-              <a:t>Some of you have used these tools daily for two years. Some have used them twice. Both are welcome, and neither is behind.</a:t>
-            </a:r>
-            <a:endParaRPr lang="en-US" sz="2000" dirty="0"/>
+              <a:t xml:space="preserve">Some of you have used these tools daily for two years. Some have used them twice. </a:t>
+            </a:r>
+            <a:r>
+              <a:rPr lang="en-US" sz="1700" b="1" dirty="0">
+                <a:solidFill>
+                  <a:srgbClr val="FFFFFF"/>
+                </a:solidFill>
+                <a:latin typeface="Calibri" pitchFamily="34" charset="0"/>
+                <a:ea typeface="Calibri" pitchFamily="34" charset="-122"/>
+                <a:cs typeface="Calibri" pitchFamily="34" charset="-120"/>
+              </a:rPr>
+              <a:t xml:space="preserve">Both are welcome, and neither is behind.</a:t>
+            </a:r>
+            <a:endParaRPr lang="en-US" sz="1700" dirty="0"/>
+          </a:p>
+        </p:txBody>
+      </p:sp>
+      <p:sp>
+        <p:nvSpPr>
+          <p:cNvPr id="10" name="Agenda heading"/>
+          <p:cNvSpPr txBox="1"/>
+          <p:nvPr/>
+        </p:nvSpPr>
+        <p:spPr>
+          <a:xfrm>
+            <a:off x="5577840" y="868680"/>
+            <a:ext cx="5699455" cy="320040"/>
+          </a:xfrm>
+          <a:prstGeom prst="rect">
+            <a:avLst/>
+          </a:prstGeom>
+          <a:noFill/>
+        </p:spPr>
+        <p:txBody>
+          <a:bodyPr wrap="square" lIns="0" tIns="0" rIns="0" bIns="0" rtlCol="0" anchor="ctr">
+            <a:normAutofit/>
+          </a:bodyPr>
+          <a:lstStyle/>
+          <a:p>
+            <a:pPr indent="0" marL="0">
+              <a:buNone/>
+            </a:pPr>
+            <a:r>
+              <a:rPr lang="en-US" sz="1150" b="1" spc="260" dirty="0">
+                <a:solidFill>
+                  <a:srgbClr val="FF6600"/>
+                </a:solidFill>
+                <a:latin typeface="Calibri" pitchFamily="34" charset="0"/>
+                <a:ea typeface="Calibri" pitchFamily="34" charset="-122"/>
+                <a:cs typeface="Calibri" pitchFamily="34" charset="-120"/>
+              </a:rPr>
+              <a:t xml:space="preserve">WHAT WE'LL COVER</a:t>
+            </a:r>
+          </a:p>
+        </p:txBody>
+      </p:sp>
+      <p:sp>
+        <p:nvSpPr>
+          <p:cNvPr id="11" name="Agenda item 1"/>
+          <p:cNvSpPr/>
+          <p:nvPr/>
+        </p:nvSpPr>
+        <p:spPr>
+          <a:xfrm>
+            <a:off x="5577840" y="1280160"/>
+            <a:ext cx="5699455" cy="868680"/>
+          </a:xfrm>
+          <a:prstGeom prst="roundRect">
+            <a:avLst>
+              <a:gd name="adj" fmla="val 12000"/>
+            </a:avLst>
+          </a:prstGeom>
+          <a:solidFill>
+            <a:srgbClr val="12263E"/>
+          </a:solidFill>
+          <a:ln>
+            <a:noFill/>
+          </a:ln>
+        </p:spPr>
+        <p:txBody>
+          <a:bodyPr wrap="square" lIns="685800" tIns="73152" rIns="182880" bIns="73152" rtlCol="0" anchor="ctr">
+            <a:normAutofit/>
+          </a:bodyPr>
+          <a:lstStyle/>
+          <a:p>
+            <a:pPr indent="0" marL="0">
+              <a:spcAft>
+                <a:spcPts val="200"/>
+              </a:spcAft>
+              <a:buNone/>
+            </a:pPr>
+            <a:r>
+              <a:rPr lang="en-US" sz="1600" b="1" dirty="0">
+                <a:solidFill>
+                  <a:srgbClr val="FFFFFF"/>
+                </a:solidFill>
+                <a:latin typeface="Poppins" pitchFamily="34" charset="0"/>
+                <a:ea typeface="Poppins" pitchFamily="34" charset="-122"/>
+                <a:cs typeface="Poppins" pitchFamily="34" charset="-120"/>
+              </a:rPr>
+              <a:t xml:space="preserve">How AI actually works</a:t>
+            </a:r>
+          </a:p>
+          <a:p>
+            <a:pPr indent="0" marL="0">
+              <a:buNone/>
+            </a:pPr>
+            <a:r>
+              <a:rPr lang="en-US" sz="1300" dirty="0">
+                <a:solidFill>
+                  <a:srgbClr val="B4C2D2"/>
+                </a:solidFill>
+                <a:latin typeface="Calibri" pitchFamily="34" charset="0"/>
+                <a:ea typeface="Calibri" pitchFamily="34" charset="-122"/>
+                <a:cs typeface="Calibri" pitchFamily="34" charset="-120"/>
+              </a:rPr>
+              <a:t xml:space="preserve">It predicts the next word. That's why it can sound right and still be wrong.</a:t>
+            </a:r>
+          </a:p>
+        </p:txBody>
+      </p:sp>
+      <p:sp>
+        <p:nvSpPr>
+          <p:cNvPr id="12" name="Agenda number 1"/>
+          <p:cNvSpPr txBox="1"/>
+          <p:nvPr/>
+        </p:nvSpPr>
+        <p:spPr>
+          <a:xfrm>
+            <a:off x="5715000" y="1280160"/>
+            <a:ext cx="457200" cy="868680"/>
+          </a:xfrm>
+          <a:prstGeom prst="rect">
+            <a:avLst/>
+          </a:prstGeom>
+          <a:noFill/>
+        </p:spPr>
+        <p:txBody>
+          <a:bodyPr wrap="square" lIns="0" tIns="0" rIns="0" bIns="0" rtlCol="0" anchor="ctr">
+            <a:normAutofit/>
+          </a:bodyPr>
+          <a:lstStyle/>
+          <a:p>
+            <a:pPr indent="0" marL="0" algn="ctr">
+              <a:buNone/>
+            </a:pPr>
+            <a:r>
+              <a:rPr lang="en-US" sz="2400" b="1" dirty="0">
+                <a:solidFill>
+                  <a:srgbClr val="FF6600"/>
+                </a:solidFill>
+                <a:latin typeface="Poppins" pitchFamily="34" charset="0"/>
+                <a:ea typeface="Poppins" pitchFamily="34" charset="-122"/>
+                <a:cs typeface="Poppins" pitchFamily="34" charset="-120"/>
+              </a:rPr>
+              <a:t xml:space="preserve">1</a:t>
+            </a:r>
+          </a:p>
+        </p:txBody>
+      </p:sp>
+      <p:sp>
+        <p:nvSpPr>
+          <p:cNvPr id="13" name="Agenda item 2"/>
+          <p:cNvSpPr/>
+          <p:nvPr/>
+        </p:nvSpPr>
+        <p:spPr>
+          <a:xfrm>
+            <a:off x="5577840" y="2240280"/>
+            <a:ext cx="5699455" cy="868680"/>
+          </a:xfrm>
+          <a:prstGeom prst="roundRect">
+            <a:avLst>
+              <a:gd name="adj" fmla="val 12000"/>
+            </a:avLst>
+          </a:prstGeom>
+          <a:solidFill>
+            <a:srgbClr val="12263E"/>
+          </a:solidFill>
+          <a:ln>
+            <a:noFill/>
+          </a:ln>
+        </p:spPr>
+        <p:txBody>
+          <a:bodyPr wrap="square" lIns="685800" tIns="73152" rIns="182880" bIns="73152" rtlCol="0" anchor="ctr">
+            <a:normAutofit/>
+          </a:bodyPr>
+          <a:lstStyle/>
+          <a:p>
+            <a:pPr indent="0" marL="0">
+              <a:spcAft>
+                <a:spcPts val="200"/>
+              </a:spcAft>
+              <a:buNone/>
+            </a:pPr>
+            <a:r>
+              <a:rPr lang="en-US" sz="1600" b="1" dirty="0">
+                <a:solidFill>
+                  <a:srgbClr val="FFFFFF"/>
+                </a:solidFill>
+                <a:latin typeface="Poppins" pitchFamily="34" charset="0"/>
+                <a:ea typeface="Poppins" pitchFamily="34" charset="-122"/>
+                <a:cs typeface="Poppins" pitchFamily="34" charset="-120"/>
+              </a:rPr>
+              <a:t xml:space="preserve">How to spot trouble early</a:t>
+            </a:r>
+          </a:p>
+          <a:p>
+            <a:pPr indent="0" marL="0">
+              <a:buNone/>
+            </a:pPr>
+            <a:r>
+              <a:rPr lang="en-US" sz="1300" dirty="0">
+                <a:solidFill>
+                  <a:srgbClr val="B4C2D2"/>
+                </a:solidFill>
+                <a:latin typeface="Calibri" pitchFamily="34" charset="0"/>
+                <a:ea typeface="Calibri" pitchFamily="34" charset="-122"/>
+                <a:cs typeface="Calibri" pitchFamily="34" charset="-120"/>
+              </a:rPr>
+              <a:t xml:space="preserve">Which tasks are risky, and a three-question check before anything leaves your desk.</a:t>
+            </a:r>
+          </a:p>
+        </p:txBody>
+      </p:sp>
+      <p:sp>
+        <p:nvSpPr>
+          <p:cNvPr id="14" name="Agenda number 2"/>
+          <p:cNvSpPr txBox="1"/>
+          <p:nvPr/>
+        </p:nvSpPr>
+        <p:spPr>
+          <a:xfrm>
+            <a:off x="5715000" y="2240280"/>
+            <a:ext cx="457200" cy="868680"/>
+          </a:xfrm>
+          <a:prstGeom prst="rect">
+            <a:avLst/>
+          </a:prstGeom>
+          <a:noFill/>
+        </p:spPr>
+        <p:txBody>
+          <a:bodyPr wrap="square" lIns="0" tIns="0" rIns="0" bIns="0" rtlCol="0" anchor="ctr">
+            <a:normAutofit/>
+          </a:bodyPr>
+          <a:lstStyle/>
+          <a:p>
+            <a:pPr indent="0" marL="0" algn="ctr">
+              <a:buNone/>
+            </a:pPr>
+            <a:r>
+              <a:rPr lang="en-US" sz="2400" b="1" dirty="0">
+                <a:solidFill>
+                  <a:srgbClr val="FF6600"/>
+                </a:solidFill>
+                <a:latin typeface="Poppins" pitchFamily="34" charset="0"/>
+                <a:ea typeface="Poppins" pitchFamily="34" charset="-122"/>
+                <a:cs typeface="Poppins" pitchFamily="34" charset="-120"/>
+              </a:rPr>
+              <a:t xml:space="preserve">2</a:t>
+            </a:r>
+          </a:p>
+        </p:txBody>
+      </p:sp>
+      <p:sp>
+        <p:nvSpPr>
+          <p:cNvPr id="15" name="Agenda item 3"/>
+          <p:cNvSpPr/>
+          <p:nvPr/>
+        </p:nvSpPr>
+        <p:spPr>
+          <a:xfrm>
+            <a:off x="5577840" y="3200400"/>
+            <a:ext cx="5699455" cy="868680"/>
+          </a:xfrm>
+          <a:prstGeom prst="roundRect">
+            <a:avLst>
+              <a:gd name="adj" fmla="val 12000"/>
+            </a:avLst>
+          </a:prstGeom>
+          <a:solidFill>
+            <a:srgbClr val="12263E"/>
+          </a:solidFill>
+          <a:ln>
+            <a:noFill/>
+          </a:ln>
+        </p:spPr>
+        <p:txBody>
+          <a:bodyPr wrap="square" lIns="685800" tIns="73152" rIns="182880" bIns="73152" rtlCol="0" anchor="ctr">
+            <a:normAutofit/>
+          </a:bodyPr>
+          <a:lstStyle/>
+          <a:p>
+            <a:pPr indent="0" marL="0">
+              <a:spcAft>
+                <a:spcPts val="200"/>
+              </a:spcAft>
+              <a:buNone/>
+            </a:pPr>
+            <a:r>
+              <a:rPr lang="en-US" sz="1600" b="1" dirty="0">
+                <a:solidFill>
+                  <a:srgbClr val="FFFFFF"/>
+                </a:solidFill>
+                <a:latin typeface="Poppins" pitchFamily="34" charset="0"/>
+                <a:ea typeface="Poppins" pitchFamily="34" charset="-122"/>
+                <a:cs typeface="Poppins" pitchFamily="34" charset="-120"/>
+              </a:rPr>
+              <a:t xml:space="preserve">How to ask it well</a:t>
+            </a:r>
+          </a:p>
+          <a:p>
+            <a:pPr indent="0" marL="0">
+              <a:buNone/>
+            </a:pPr>
+            <a:r>
+              <a:rPr lang="en-US" sz="1300" dirty="0">
+                <a:solidFill>
+                  <a:srgbClr val="B4C2D2"/>
+                </a:solidFill>
+                <a:latin typeface="Calibri" pitchFamily="34" charset="0"/>
+                <a:ea typeface="Calibri" pitchFamily="34" charset="-122"/>
+                <a:cs typeface="Calibri" pitchFamily="34" charset="-120"/>
+              </a:rPr>
+              <a:t xml:space="preserve">Four moves that get better answers, and when to stop trying.</a:t>
+            </a:r>
+          </a:p>
+        </p:txBody>
+      </p:sp>
+      <p:sp>
+        <p:nvSpPr>
+          <p:cNvPr id="16" name="Agenda number 3"/>
+          <p:cNvSpPr txBox="1"/>
+          <p:nvPr/>
+        </p:nvSpPr>
+        <p:spPr>
+          <a:xfrm>
+            <a:off x="5715000" y="3200400"/>
+            <a:ext cx="457200" cy="868680"/>
+          </a:xfrm>
+          <a:prstGeom prst="rect">
+            <a:avLst/>
+          </a:prstGeom>
+          <a:noFill/>
+        </p:spPr>
+        <p:txBody>
+          <a:bodyPr wrap="square" lIns="0" tIns="0" rIns="0" bIns="0" rtlCol="0" anchor="ctr">
+            <a:normAutofit/>
+          </a:bodyPr>
+          <a:lstStyle/>
+          <a:p>
+            <a:pPr indent="0" marL="0" algn="ctr">
+              <a:buNone/>
+            </a:pPr>
+            <a:r>
+              <a:rPr lang="en-US" sz="2400" b="1" dirty="0">
+                <a:solidFill>
+                  <a:srgbClr val="FF6600"/>
+                </a:solidFill>
+                <a:latin typeface="Poppins" pitchFamily="34" charset="0"/>
+                <a:ea typeface="Poppins" pitchFamily="34" charset="-122"/>
+                <a:cs typeface="Poppins" pitchFamily="34" charset="-120"/>
+              </a:rPr>
+              <a:t xml:space="preserve">3</a:t>
+            </a:r>
+          </a:p>
+        </p:txBody>
+      </p:sp>
+      <p:sp>
+        <p:nvSpPr>
+          <p:cNvPr id="17" name="Agenda item 4"/>
+          <p:cNvSpPr/>
+          <p:nvPr/>
+        </p:nvSpPr>
+        <p:spPr>
+          <a:xfrm>
+            <a:off x="5577840" y="4160520"/>
+            <a:ext cx="5699455" cy="868680"/>
+          </a:xfrm>
+          <a:prstGeom prst="roundRect">
+            <a:avLst>
+              <a:gd name="adj" fmla="val 12000"/>
+            </a:avLst>
+          </a:prstGeom>
+          <a:solidFill>
+            <a:srgbClr val="12263E"/>
+          </a:solidFill>
+          <a:ln>
+            <a:noFill/>
+          </a:ln>
+        </p:spPr>
+        <p:txBody>
+          <a:bodyPr wrap="square" lIns="685800" tIns="73152" rIns="182880" bIns="73152" rtlCol="0" anchor="ctr">
+            <a:normAutofit/>
+          </a:bodyPr>
+          <a:lstStyle/>
+          <a:p>
+            <a:pPr indent="0" marL="0">
+              <a:spcAft>
+                <a:spcPts val="200"/>
+              </a:spcAft>
+              <a:buNone/>
+            </a:pPr>
+            <a:r>
+              <a:rPr lang="en-US" sz="1600" b="1" dirty="0">
+                <a:solidFill>
+                  <a:srgbClr val="FFFFFF"/>
+                </a:solidFill>
+                <a:latin typeface="Poppins" pitchFamily="34" charset="0"/>
+                <a:ea typeface="Poppins" pitchFamily="34" charset="-122"/>
+                <a:cs typeface="Poppins" pitchFamily="34" charset="-120"/>
+              </a:rPr>
+              <a:t xml:space="preserve">What never goes into AI</a:t>
+            </a:r>
+          </a:p>
+          <a:p>
+            <a:pPr indent="0" marL="0">
+              <a:buNone/>
+            </a:pPr>
+            <a:r>
+              <a:rPr lang="en-US" sz="1300" dirty="0">
+                <a:solidFill>
+                  <a:srgbClr val="B4C2D2"/>
+                </a:solidFill>
+                <a:latin typeface="Calibri" pitchFamily="34" charset="0"/>
+                <a:ea typeface="Calibri" pitchFamily="34" charset="-122"/>
+                <a:cs typeface="Calibri" pitchFamily="34" charset="-120"/>
+              </a:rPr>
+              <a:t xml:space="preserve">Student records, financial aid data, and the green, yellow, red line.</a:t>
+            </a:r>
+          </a:p>
+        </p:txBody>
+      </p:sp>
+      <p:sp>
+        <p:nvSpPr>
+          <p:cNvPr id="18" name="Agenda number 4"/>
+          <p:cNvSpPr txBox="1"/>
+          <p:nvPr/>
+        </p:nvSpPr>
+        <p:spPr>
+          <a:xfrm>
+            <a:off x="5715000" y="4160520"/>
+            <a:ext cx="457200" cy="868680"/>
+          </a:xfrm>
+          <a:prstGeom prst="rect">
+            <a:avLst/>
+          </a:prstGeom>
+          <a:noFill/>
+        </p:spPr>
+        <p:txBody>
+          <a:bodyPr wrap="square" lIns="0" tIns="0" rIns="0" bIns="0" rtlCol="0" anchor="ctr">
+            <a:normAutofit/>
+          </a:bodyPr>
+          <a:lstStyle/>
+          <a:p>
+            <a:pPr indent="0" marL="0" algn="ctr">
+              <a:buNone/>
+            </a:pPr>
+            <a:r>
+              <a:rPr lang="en-US" sz="2400" b="1" dirty="0">
+                <a:solidFill>
+                  <a:srgbClr val="FF6600"/>
+                </a:solidFill>
+                <a:latin typeface="Poppins" pitchFamily="34" charset="0"/>
+                <a:ea typeface="Poppins" pitchFamily="34" charset="-122"/>
+                <a:cs typeface="Poppins" pitchFamily="34" charset="-120"/>
+              </a:rPr>
+              <a:t xml:space="preserve">4</a:t>
+            </a:r>
+          </a:p>
+        </p:txBody>
+      </p:sp>
+      <p:sp>
+        <p:nvSpPr>
+          <p:cNvPr id="19" name="Agenda item 5"/>
+          <p:cNvSpPr/>
+          <p:nvPr/>
+        </p:nvSpPr>
+        <p:spPr>
+          <a:xfrm>
+            <a:off x="5577840" y="5120640"/>
+            <a:ext cx="5699455" cy="868680"/>
+          </a:xfrm>
+          <a:prstGeom prst="roundRect">
+            <a:avLst>
+              <a:gd name="adj" fmla="val 12000"/>
+            </a:avLst>
+          </a:prstGeom>
+          <a:solidFill>
+            <a:srgbClr val="12263E"/>
+          </a:solidFill>
+          <a:ln>
+            <a:noFill/>
+          </a:ln>
+        </p:spPr>
+        <p:txBody>
+          <a:bodyPr wrap="square" lIns="685800" tIns="73152" rIns="182880" bIns="73152" rtlCol="0" anchor="ctr">
+            <a:normAutofit/>
+          </a:bodyPr>
+          <a:lstStyle/>
+          <a:p>
+            <a:pPr indent="0" marL="0">
+              <a:spcAft>
+                <a:spcPts val="200"/>
+              </a:spcAft>
+              <a:buNone/>
+            </a:pPr>
+            <a:r>
+              <a:rPr lang="en-US" sz="1600" b="1" dirty="0">
+                <a:solidFill>
+                  <a:srgbClr val="FFFFFF"/>
+                </a:solidFill>
+                <a:latin typeface="Poppins" pitchFamily="34" charset="0"/>
+                <a:ea typeface="Poppins" pitchFamily="34" charset="-122"/>
+                <a:cs typeface="Poppins" pitchFamily="34" charset="-120"/>
+              </a:rPr>
+              <a:t xml:space="preserve">Two habits to keep</a:t>
+            </a:r>
+          </a:p>
+          <a:p>
+            <a:pPr indent="0" marL="0">
+              <a:buNone/>
+            </a:pPr>
+            <a:r>
+              <a:rPr lang="en-US" sz="1300" dirty="0">
+                <a:solidFill>
+                  <a:srgbClr val="B4C2D2"/>
+                </a:solidFill>
+                <a:latin typeface="Calibri" pitchFamily="34" charset="0"/>
+                <a:ea typeface="Calibri" pitchFamily="34" charset="-122"/>
+                <a:cs typeface="Calibri" pitchFamily="34" charset="-120"/>
+              </a:rPr>
+              <a:t xml:space="preserve">Sign in with your MCC account, and no AI notetakers in sensitive meetings.</a:t>
+            </a:r>
+          </a:p>
+        </p:txBody>
+      </p:sp>
+      <p:sp>
+        <p:nvSpPr>
+          <p:cNvPr id="20" name="Agenda number 5"/>
+          <p:cNvSpPr txBox="1"/>
+          <p:nvPr/>
+        </p:nvSpPr>
+        <p:spPr>
+          <a:xfrm>
+            <a:off x="5715000" y="5120640"/>
+            <a:ext cx="457200" cy="868680"/>
+          </a:xfrm>
+          <a:prstGeom prst="rect">
+            <a:avLst/>
+          </a:prstGeom>
+          <a:noFill/>
+        </p:spPr>
+        <p:txBody>
+          <a:bodyPr wrap="square" lIns="0" tIns="0" rIns="0" bIns="0" rtlCol="0" anchor="ctr">
+            <a:normAutofit/>
+          </a:bodyPr>
+          <a:lstStyle/>
+          <a:p>
+            <a:pPr indent="0" marL="0" algn="ctr">
+              <a:buNone/>
+            </a:pPr>
+            <a:r>
+              <a:rPr lang="en-US" sz="2400" b="1" dirty="0">
+                <a:solidFill>
+                  <a:srgbClr val="FF6600"/>
+                </a:solidFill>
+                <a:latin typeface="Poppins" pitchFamily="34" charset="0"/>
+                <a:ea typeface="Poppins" pitchFamily="34" charset="-122"/>
+                <a:cs typeface="Poppins" pitchFamily="34" charset="-120"/>
+              </a:rPr>
+              <a:t xml:space="preserve">5</a:t>
+            </a:r>
           </a:p>
         </p:txBody>
       </p:sp>

</xml_diff>